<commit_message>
long beach ingress/egress pilot
</commit_message>
<xml_diff>
--- a/07_presentations/razor-clam-sampling-design.pptx
+++ b/07_presentations/razor-clam-sampling-design.pptx
@@ -4,29 +4,30 @@
   <p:sldMasterIdLst>
     <p:sldMasterId id="2147483648" r:id="rId4"/>
   </p:sldMasterIdLst>
-  <p:notesMasterIdLst>
-    <p:notesMasterId r:id="rId21"/>
-  </p:notesMasterIdLst>
   <p:handoutMasterIdLst>
-    <p:handoutMasterId r:id="rId22"/>
+    <p:handoutMasterId r:id="rId19"/>
   </p:handoutMasterIdLst>
   <p:sldIdLst>
-    <p:sldId id="256" r:id="rId5"/>
-    <p:sldId id="257" r:id="rId6"/>
-    <p:sldId id="258" r:id="rId7"/>
-    <p:sldId id="259" r:id="rId8"/>
-    <p:sldId id="260" r:id="rId9"/>
-    <p:sldId id="261" r:id="rId10"/>
-    <p:sldId id="262" r:id="rId11"/>
-    <p:sldId id="263" r:id="rId12"/>
-    <p:sldId id="264" r:id="rId13"/>
-    <p:sldId id="265" r:id="rId14"/>
-    <p:sldId id="266" r:id="rId15"/>
-    <p:sldId id="267" r:id="rId16"/>
-    <p:sldId id="268" r:id="rId17"/>
-    <p:sldId id="269" r:id="rId18"/>
-    <p:sldId id="270" r:id="rId19"/>
-    <p:sldId id="271" r:id="rId20"/>
+    <p:sldId id="256" r:id="rId11"/>
+    <p:sldId id="257" r:id="rId13"/>
+    <p:sldId id="258" r:id="rId14"/>
+    <p:sldId id="259" r:id="rId15"/>
+    <p:sldId id="260" r:id="rId16"/>
+    <p:sldId id="261" r:id="rId17"/>
+    <p:sldId id="262" r:id="rId18"/>
+    <p:sldId id="263" r:id="rId10"/>
+    <p:sldId id="264" r:id="rId9"/>
+    <p:sldId id="265" r:id="rId8"/>
+    <p:sldId id="266" r:id="rId7"/>
+    <p:sldId id="267" r:id="rId6"/>
+    <p:sldId id="268" r:id="rId5"/>
+    <p:sldId id="269" r:id="rId25"/>
+    <p:sldId id="270" r:id="rId26"/>
+    <p:sldId id="271" r:id="rId27"/>
+    <p:sldId id="272" r:id="rId28"/>
+    <p:sldId id="273" r:id="rId29"/>
+    <p:sldId id="274" r:id="rId30"/>
+    <p:sldId id="275" r:id="rId31"/>
   </p:sldIdLst>
   <p:sldSz cx="12192000" cy="6858000"/>
   <p:notesSz cx="6858000" cy="9144000"/>
@@ -237,7 +238,7 @@
           <a:p>
             <a:fld id="{DAA1D058-9860-4C37-9D21-AC6EFE975A47}" type="datetimeFigureOut">
               <a:rPr lang="en-US" smtClean="0"/>
-              <a:t>7/13/2026</a:t>
+              <a:t>3/12/2026</a:t>
             </a:fld>
             <a:endParaRPr lang="en-US"/>
           </a:p>
@@ -333,7 +334,7 @@
 </file>
 
 <file path=ppt/notesMasters/notesMaster1.xml><?xml version="1.0" encoding="utf-8"?>
-<p:notesMaster xmlns:a="http://schemas.openxmlformats.org/drawingml/2006/main" xmlns:r="http://schemas.openxmlformats.org/officeDocument/2006/relationships" xmlns:p="http://schemas.openxmlformats.org/presentationml/2006/main">
+<p:notesMaster xmlns:a="http://schemas.openxmlformats.org/drawingml/2006/main" xmlns:p="http://schemas.openxmlformats.org/presentationml/2006/main" xmlns:r="http://schemas.openxmlformats.org/officeDocument/2006/relationships">
   <p:cSld>
     <p:bg>
       <p:bgRef idx="1001">
@@ -354,16 +355,241 @@
           <a:chExt cx="0" cy="0"/>
         </a:xfrm>
       </p:grpSpPr>
+      <p:sp>
+        <p:nvSpPr>
+          <p:cNvPr id="2" name="Header Placeholder 1"/>
+          <p:cNvSpPr>
+            <a:spLocks noGrp="1"/>
+          </p:cNvSpPr>
+          <p:nvPr>
+            <p:ph type="hdr" sz="quarter"/>
+          </p:nvPr>
+        </p:nvSpPr>
+        <p:spPr>
+          <a:xfrm>
+            <a:off x="0" y="0"/>
+            <a:ext cx="2971800" cy="457200"/>
+          </a:xfrm>
+          <a:prstGeom prst="rect">
+            <a:avLst/>
+          </a:prstGeom>
+        </p:spPr>
+        <p:txBody>
+          <a:bodyPr vert="horz" lIns="91440" tIns="45720" rIns="91440" bIns="45720" rtlCol="0"/>
+          <a:lstStyle>
+            <a:lvl1pPr algn="l">
+              <a:defRPr sz="1200"/>
+            </a:lvl1pPr>
+          </a:lstStyle>
+          <a:p>
+            <a:endParaRPr lang="en-US"/>
+          </a:p>
+        </p:txBody>
+      </p:sp>
+      <p:sp>
+        <p:nvSpPr>
+          <p:cNvPr id="3" name="Date Placeholder 2"/>
+          <p:cNvSpPr>
+            <a:spLocks noGrp="1"/>
+          </p:cNvSpPr>
+          <p:nvPr>
+            <p:ph type="dt" idx="1"/>
+          </p:nvPr>
+        </p:nvSpPr>
+        <p:spPr>
+          <a:xfrm>
+            <a:off x="3884613" y="0"/>
+            <a:ext cx="2971800" cy="457200"/>
+          </a:xfrm>
+          <a:prstGeom prst="rect">
+            <a:avLst/>
+          </a:prstGeom>
+        </p:spPr>
+        <p:txBody>
+          <a:bodyPr vert="horz" lIns="91440" tIns="45720" rIns="91440" bIns="45720" rtlCol="0"/>
+          <a:lstStyle>
+            <a:lvl1pPr algn="r">
+              <a:defRPr sz="1200"/>
+            </a:lvl1pPr>
+          </a:lstStyle>
+          <a:p>
+            <a:fld id="{0F89C1C7-3DCD-1040-A9CF-14679D8B5DDD}" type="datetimeFigureOut">
+              <a:rPr lang="en-US" smtClean="0"/>
+              <a:t>10/17/16</a:t>
+            </a:fld>
+            <a:endParaRPr lang="en-US"/>
+          </a:p>
+        </p:txBody>
+      </p:sp>
+      <p:sp>
+        <p:nvSpPr>
+          <p:cNvPr id="4" name="Slide Image Placeholder 3"/>
+          <p:cNvSpPr>
+            <a:spLocks noGrp="1" noRot="1" noChangeAspect="1"/>
+          </p:cNvSpPr>
+          <p:nvPr>
+            <p:ph type="sldImg" idx="2"/>
+          </p:nvPr>
+        </p:nvSpPr>
+        <p:spPr>
+          <a:xfrm>
+            <a:off x="1143000" y="685800"/>
+            <a:ext cx="4572000" cy="3429000"/>
+          </a:xfrm>
+          <a:prstGeom prst="rect">
+            <a:avLst/>
+          </a:prstGeom>
+          <a:noFill/>
+          <a:ln w="12700">
+            <a:solidFill>
+              <a:prstClr val="black"/>
+            </a:solidFill>
+          </a:ln>
+        </p:spPr>
+        <p:txBody>
+          <a:bodyPr vert="horz" lIns="91440" tIns="45720" rIns="91440" bIns="45720" rtlCol="0" anchor="ctr"/>
+          <a:lstStyle/>
+          <a:p>
+            <a:endParaRPr lang="en-US"/>
+          </a:p>
+        </p:txBody>
+      </p:sp>
+      <p:sp>
+        <p:nvSpPr>
+          <p:cNvPr id="5" name="Notes Placeholder 4"/>
+          <p:cNvSpPr>
+            <a:spLocks noGrp="1"/>
+          </p:cNvSpPr>
+          <p:nvPr>
+            <p:ph type="body" sz="quarter" idx="3"/>
+          </p:nvPr>
+        </p:nvSpPr>
+        <p:spPr>
+          <a:xfrm>
+            <a:off x="685800" y="4343400"/>
+            <a:ext cx="5486400" cy="4114800"/>
+          </a:xfrm>
+          <a:prstGeom prst="rect">
+            <a:avLst/>
+          </a:prstGeom>
+        </p:spPr>
+        <p:txBody>
+          <a:bodyPr vert="horz" lIns="91440" tIns="45720" rIns="91440" bIns="45720" rtlCol="0"/>
+          <a:lstStyle/>
+          <a:p>
+            <a:pPr lvl="0"/>
+            <a:r>
+              <a:rPr lang="en-US" smtClean="0"/>
+              <a:t>Click to edit Master text styles</a:t>
+            </a:r>
+          </a:p>
+          <a:p>
+            <a:pPr lvl="1"/>
+            <a:r>
+              <a:rPr lang="en-US" smtClean="0"/>
+              <a:t>Second level</a:t>
+            </a:r>
+          </a:p>
+          <a:p>
+            <a:pPr lvl="2"/>
+            <a:r>
+              <a:rPr lang="en-US" smtClean="0"/>
+              <a:t>Third level</a:t>
+            </a:r>
+          </a:p>
+          <a:p>
+            <a:pPr lvl="3"/>
+            <a:r>
+              <a:rPr lang="en-US" smtClean="0"/>
+              <a:t>Fourth level</a:t>
+            </a:r>
+          </a:p>
+          <a:p>
+            <a:pPr lvl="4"/>
+            <a:r>
+              <a:rPr lang="en-US" smtClean="0"/>
+              <a:t>Fifth level</a:t>
+            </a:r>
+            <a:endParaRPr lang="en-US"/>
+          </a:p>
+        </p:txBody>
+      </p:sp>
+      <p:sp>
+        <p:nvSpPr>
+          <p:cNvPr id="6" name="Footer Placeholder 5"/>
+          <p:cNvSpPr>
+            <a:spLocks noGrp="1"/>
+          </p:cNvSpPr>
+          <p:nvPr>
+            <p:ph type="ftr" sz="quarter" idx="4"/>
+          </p:nvPr>
+        </p:nvSpPr>
+        <p:spPr>
+          <a:xfrm>
+            <a:off x="0" y="8685213"/>
+            <a:ext cx="2971800" cy="457200"/>
+          </a:xfrm>
+          <a:prstGeom prst="rect">
+            <a:avLst/>
+          </a:prstGeom>
+        </p:spPr>
+        <p:txBody>
+          <a:bodyPr vert="horz" lIns="91440" tIns="45720" rIns="91440" bIns="45720" rtlCol="0" anchor="b"/>
+          <a:lstStyle>
+            <a:lvl1pPr algn="l">
+              <a:defRPr sz="1200"/>
+            </a:lvl1pPr>
+          </a:lstStyle>
+          <a:p>
+            <a:endParaRPr lang="en-US"/>
+          </a:p>
+        </p:txBody>
+      </p:sp>
+      <p:sp>
+        <p:nvSpPr>
+          <p:cNvPr id="7" name="Slide Number Placeholder 6"/>
+          <p:cNvSpPr>
+            <a:spLocks noGrp="1"/>
+          </p:cNvSpPr>
+          <p:nvPr>
+            <p:ph type="sldNum" sz="quarter" idx="5"/>
+          </p:nvPr>
+        </p:nvSpPr>
+        <p:spPr>
+          <a:xfrm>
+            <a:off x="3884613" y="8685213"/>
+            <a:ext cx="2971800" cy="457200"/>
+          </a:xfrm>
+          <a:prstGeom prst="rect">
+            <a:avLst/>
+          </a:prstGeom>
+        </p:spPr>
+        <p:txBody>
+          <a:bodyPr vert="horz" lIns="91440" tIns="45720" rIns="91440" bIns="45720" rtlCol="0" anchor="b"/>
+          <a:lstStyle>
+            <a:lvl1pPr algn="r">
+              <a:defRPr sz="1200"/>
+            </a:lvl1pPr>
+          </a:lstStyle>
+          <a:p>
+            <a:fld id="{BB5E49A5-4136-284D-997B-48E1D791AD67}" type="slidenum">
+              <a:rPr lang="en-US" smtClean="0"/>
+              <a:t>‹#›</a:t>
+            </a:fld>
+            <a:endParaRPr lang="en-US"/>
+          </a:p>
+        </p:txBody>
+      </p:sp>
     </p:spTree>
     <p:extLst>
       <p:ext uri="{BB962C8B-B14F-4D97-AF65-F5344CB8AC3E}">
-        <p14:creationId xmlns:p14="http://schemas.microsoft.com/office/powerpoint/2010/main" val="1327163138"/>
+        <p14:creationId xmlns:p14="http://schemas.microsoft.com/office/powerpoint/2010/main" val="2623252185"/>
       </p:ext>
     </p:extLst>
   </p:cSld>
   <p:clrMap bg1="lt1" tx1="dk1" bg2="lt2" tx2="dk2" accent1="accent1" accent2="accent2" accent3="accent3" accent4="accent4" accent5="accent5" accent6="accent6" hlink="hlink" folHlink="folHlink"/>
   <p:notesStyle>
-    <a:lvl1pPr marL="0" algn="l" defTabSz="914400" rtl="0" eaLnBrk="1" latinLnBrk="0" hangingPunct="1">
+    <a:lvl1pPr marL="0" algn="l" defTabSz="457200" rtl="0" eaLnBrk="1" latinLnBrk="0" hangingPunct="1">
       <a:defRPr sz="1200" kern="1200">
         <a:solidFill>
           <a:schemeClr val="tx1"/>
@@ -373,7 +599,7 @@
         <a:cs typeface="+mn-cs"/>
       </a:defRPr>
     </a:lvl1pPr>
-    <a:lvl2pPr marL="457200" algn="l" defTabSz="914400" rtl="0" eaLnBrk="1" latinLnBrk="0" hangingPunct="1">
+    <a:lvl2pPr marL="457200" algn="l" defTabSz="457200" rtl="0" eaLnBrk="1" latinLnBrk="0" hangingPunct="1">
       <a:defRPr sz="1200" kern="1200">
         <a:solidFill>
           <a:schemeClr val="tx1"/>
@@ -383,7 +609,7 @@
         <a:cs typeface="+mn-cs"/>
       </a:defRPr>
     </a:lvl2pPr>
-    <a:lvl3pPr marL="914400" algn="l" defTabSz="914400" rtl="0" eaLnBrk="1" latinLnBrk="0" hangingPunct="1">
+    <a:lvl3pPr marL="914400" algn="l" defTabSz="457200" rtl="0" eaLnBrk="1" latinLnBrk="0" hangingPunct="1">
       <a:defRPr sz="1200" kern="1200">
         <a:solidFill>
           <a:schemeClr val="tx1"/>
@@ -393,7 +619,7 @@
         <a:cs typeface="+mn-cs"/>
       </a:defRPr>
     </a:lvl3pPr>
-    <a:lvl4pPr marL="1371600" algn="l" defTabSz="914400" rtl="0" eaLnBrk="1" latinLnBrk="0" hangingPunct="1">
+    <a:lvl4pPr marL="1371600" algn="l" defTabSz="457200" rtl="0" eaLnBrk="1" latinLnBrk="0" hangingPunct="1">
       <a:defRPr sz="1200" kern="1200">
         <a:solidFill>
           <a:schemeClr val="tx1"/>
@@ -403,7 +629,7 @@
         <a:cs typeface="+mn-cs"/>
       </a:defRPr>
     </a:lvl4pPr>
-    <a:lvl5pPr marL="1828800" algn="l" defTabSz="914400" rtl="0" eaLnBrk="1" latinLnBrk="0" hangingPunct="1">
+    <a:lvl5pPr marL="1828800" algn="l" defTabSz="457200" rtl="0" eaLnBrk="1" latinLnBrk="0" hangingPunct="1">
       <a:defRPr sz="1200" kern="1200">
         <a:solidFill>
           <a:schemeClr val="tx1"/>
@@ -413,7 +639,7 @@
         <a:cs typeface="+mn-cs"/>
       </a:defRPr>
     </a:lvl5pPr>
-    <a:lvl6pPr marL="2286000" algn="l" defTabSz="914400" rtl="0" eaLnBrk="1" latinLnBrk="0" hangingPunct="1">
+    <a:lvl6pPr marL="2286000" algn="l" defTabSz="457200" rtl="0" eaLnBrk="1" latinLnBrk="0" hangingPunct="1">
       <a:defRPr sz="1200" kern="1200">
         <a:solidFill>
           <a:schemeClr val="tx1"/>
@@ -423,7 +649,7 @@
         <a:cs typeface="+mn-cs"/>
       </a:defRPr>
     </a:lvl6pPr>
-    <a:lvl7pPr marL="2743200" algn="l" defTabSz="914400" rtl="0" eaLnBrk="1" latinLnBrk="0" hangingPunct="1">
+    <a:lvl7pPr marL="2743200" algn="l" defTabSz="457200" rtl="0" eaLnBrk="1" latinLnBrk="0" hangingPunct="1">
       <a:defRPr sz="1200" kern="1200">
         <a:solidFill>
           <a:schemeClr val="tx1"/>
@@ -433,7 +659,7 @@
         <a:cs typeface="+mn-cs"/>
       </a:defRPr>
     </a:lvl7pPr>
-    <a:lvl8pPr marL="3200400" algn="l" defTabSz="914400" rtl="0" eaLnBrk="1" latinLnBrk="0" hangingPunct="1">
+    <a:lvl8pPr marL="3200400" algn="l" defTabSz="457200" rtl="0" eaLnBrk="1" latinLnBrk="0" hangingPunct="1">
       <a:defRPr sz="1200" kern="1200">
         <a:solidFill>
           <a:schemeClr val="tx1"/>
@@ -443,7 +669,7 @@
         <a:cs typeface="+mn-cs"/>
       </a:defRPr>
     </a:lvl8pPr>
-    <a:lvl9pPr marL="3657600" algn="l" defTabSz="914400" rtl="0" eaLnBrk="1" latinLnBrk="0" hangingPunct="1">
+    <a:lvl9pPr marL="3657600" algn="l" defTabSz="457200" rtl="0" eaLnBrk="1" latinLnBrk="0" hangingPunct="1">
       <a:defRPr sz="1200" kern="1200">
         <a:solidFill>
           <a:schemeClr val="tx1"/>
@@ -458,7 +684,7 @@
 </file>
 
 <file path=ppt/notesSlides/notesSlide1.xml><?xml version="1.0" encoding="utf-8"?>
-<p:notes xmlns:a="http://schemas.openxmlformats.org/drawingml/2006/main" xmlns:r="http://schemas.openxmlformats.org/officeDocument/2006/relationships" xmlns:p="http://schemas.openxmlformats.org/presentationml/2006/main">
+<p:notes xmlns:a="http://schemas.openxmlformats.org/drawingml/2006/main" xmlns:p="http://schemas.openxmlformats.org/presentationml/2006/main" xmlns:r="http://schemas.openxmlformats.org/officeDocument/2006/relationships">
   <p:cSld>
     <p:spTree>
       <p:nvGrpSpPr>
@@ -478,7 +704,7 @@
         <p:nvSpPr>
           <p:cNvPr id="2" name="Slide Image Placeholder 1"/>
           <p:cNvSpPr>
-            <a:spLocks noGrp="1" noRot="1" noChangeAspect="1"/>
+            <a:spLocks noGrp="1"/>
           </p:cNvSpPr>
           <p:nvPr>
             <p:ph type="sldImg" idx="2"/>
@@ -493,7 +719,7 @@
             <a:spLocks noGrp="1"/>
           </p:cNvSpPr>
           <p:nvPr>
-            <p:ph type="body" sz="quarter" idx="3"/>
+            <p:ph type="body" idx="3" sz="quarter"/>
           </p:nvPr>
         </p:nvSpPr>
         <p:spPr/>
@@ -514,7 +740,7 @@
             <a:spLocks noGrp="1"/>
           </p:cNvSpPr>
           <p:nvPr>
-            <p:ph type="sldNum" sz="quarter" idx="5"/>
+            <p:ph type="sldNum" idx="5" sz="quarter"/>
           </p:nvPr>
         </p:nvSpPr>
         <p:spPr/>
@@ -528,7 +754,7 @@
 </file>
 
 <file path=ppt/notesSlides/notesSlide10.xml><?xml version="1.0" encoding="utf-8"?>
-<p:notes xmlns:a="http://schemas.openxmlformats.org/drawingml/2006/main" xmlns:r="http://schemas.openxmlformats.org/officeDocument/2006/relationships" xmlns:p="http://schemas.openxmlformats.org/presentationml/2006/main">
+<p:notes xmlns:a="http://schemas.openxmlformats.org/drawingml/2006/main" xmlns:p="http://schemas.openxmlformats.org/presentationml/2006/main" xmlns:r="http://schemas.openxmlformats.org/officeDocument/2006/relationships">
   <p:cSld>
     <p:spTree>
       <p:nvGrpSpPr>
@@ -548,7 +774,7 @@
         <p:nvSpPr>
           <p:cNvPr id="2" name="Slide Image Placeholder 1"/>
           <p:cNvSpPr>
-            <a:spLocks noGrp="1" noRot="1" noChangeAspect="1"/>
+            <a:spLocks noGrp="1"/>
           </p:cNvSpPr>
           <p:nvPr>
             <p:ph type="sldImg" idx="2"/>
@@ -563,7 +789,7 @@
             <a:spLocks noGrp="1"/>
           </p:cNvSpPr>
           <p:nvPr>
-            <p:ph type="body" sz="quarter" idx="3"/>
+            <p:ph type="body" idx="3" sz="quarter"/>
           </p:nvPr>
         </p:nvSpPr>
         <p:spPr/>
@@ -584,7 +810,7 @@
             <a:spLocks noGrp="1"/>
           </p:cNvSpPr>
           <p:nvPr>
-            <p:ph type="sldNum" sz="quarter" idx="5"/>
+            <p:ph type="sldNum" idx="5" sz="quarter"/>
           </p:nvPr>
         </p:nvSpPr>
         <p:spPr/>
@@ -598,7 +824,7 @@
 </file>
 
 <file path=ppt/notesSlides/notesSlide11.xml><?xml version="1.0" encoding="utf-8"?>
-<p:notes xmlns:a="http://schemas.openxmlformats.org/drawingml/2006/main" xmlns:r="http://schemas.openxmlformats.org/officeDocument/2006/relationships" xmlns:p="http://schemas.openxmlformats.org/presentationml/2006/main">
+<p:notes xmlns:a="http://schemas.openxmlformats.org/drawingml/2006/main" xmlns:p="http://schemas.openxmlformats.org/presentationml/2006/main" xmlns:r="http://schemas.openxmlformats.org/officeDocument/2006/relationships">
   <p:cSld>
     <p:spTree>
       <p:nvGrpSpPr>
@@ -618,7 +844,7 @@
         <p:nvSpPr>
           <p:cNvPr id="2" name="Slide Image Placeholder 1"/>
           <p:cNvSpPr>
-            <a:spLocks noGrp="1" noRot="1" noChangeAspect="1"/>
+            <a:spLocks noGrp="1"/>
           </p:cNvSpPr>
           <p:nvPr>
             <p:ph type="sldImg" idx="2"/>
@@ -633,7 +859,7 @@
             <a:spLocks noGrp="1"/>
           </p:cNvSpPr>
           <p:nvPr>
-            <p:ph type="body" sz="quarter" idx="3"/>
+            <p:ph type="body" idx="3" sz="quarter"/>
           </p:nvPr>
         </p:nvSpPr>
         <p:spPr/>
@@ -642,7 +868,7 @@
           <a:lstStyle/>
           <a:p>
             <a:r>
-              <a:t>Sec 11.6 + new analysis (Fig 15). The tribal data-share turns the caveat into an upgrade.</a:t>
+              <a:t>Sec 11.6-11.7 + revised Fig 15. Correction: the Quinault alternate-day fishery is NOT a state proxy, so there is no offsetting data-share. The cost of thinning the donor is real and unoffset. This is why the recommendation is to hold the donor at its co-management floor and fund Long Beach from the pilot instead.</a:t>
             </a:r>
           </a:p>
         </p:txBody>
@@ -654,7 +880,7 @@
             <a:spLocks noGrp="1"/>
           </p:cNvSpPr>
           <p:nvPr>
-            <p:ph type="sldNum" sz="quarter" idx="5"/>
+            <p:ph type="sldNum" idx="5" sz="quarter"/>
           </p:nvPr>
         </p:nvSpPr>
         <p:spPr/>
@@ -668,7 +894,7 @@
 </file>
 
 <file path=ppt/notesSlides/notesSlide12.xml><?xml version="1.0" encoding="utf-8"?>
-<p:notes xmlns:a="http://schemas.openxmlformats.org/drawingml/2006/main" xmlns:r="http://schemas.openxmlformats.org/officeDocument/2006/relationships" xmlns:p="http://schemas.openxmlformats.org/presentationml/2006/main">
+<p:notes xmlns:a="http://schemas.openxmlformats.org/drawingml/2006/main" xmlns:p="http://schemas.openxmlformats.org/presentationml/2006/main" xmlns:r="http://schemas.openxmlformats.org/officeDocument/2006/relationships">
   <p:cSld>
     <p:spTree>
       <p:nvGrpSpPr>
@@ -688,7 +914,7 @@
         <p:nvSpPr>
           <p:cNvPr id="2" name="Slide Image Placeholder 1"/>
           <p:cNvSpPr>
-            <a:spLocks noGrp="1" noRot="1" noChangeAspect="1"/>
+            <a:spLocks noGrp="1"/>
           </p:cNvSpPr>
           <p:nvPr>
             <p:ph type="sldImg" idx="2"/>
@@ -703,7 +929,7 @@
             <a:spLocks noGrp="1"/>
           </p:cNvSpPr>
           <p:nvPr>
-            <p:ph type="body" sz="quarter" idx="3"/>
+            <p:ph type="body" idx="3" sz="quarter"/>
           </p:nvPr>
         </p:nvSpPr>
         <p:spPr/>
@@ -712,7 +938,7 @@
           <a:lstStyle/>
           <a:p>
             <a:r>
-              <a:t>The four recommendations. #1 and #3 are the ones with the highest leverage.</a:t>
+              <a:t>Sources: INGRESSPLAN98.docx (method, one counter per approach); consolidated IE inventory (Long Beach surveys were Oysterville-north-only or Seaview-south-only, never whole-beach); wdfw02656.pdf (7-section effort structure; the six drivable approaches are Seaview, Long Beach/Bolstad, Cranberry, Klipsan, Ocean Park, Oysterville).</a:t>
             </a:r>
           </a:p>
         </p:txBody>
@@ -724,7 +950,7 @@
             <a:spLocks noGrp="1"/>
           </p:cNvSpPr>
           <p:nvPr>
-            <p:ph type="sldNum" sz="quarter" idx="5"/>
+            <p:ph type="sldNum" idx="5" sz="quarter"/>
           </p:nvPr>
         </p:nvSpPr>
         <p:spPr/>
@@ -737,8 +963,8 @@
 </p:notes>
 </file>
 
-<file path=ppt/notesSlides/notesSlide2.xml><?xml version="1.0" encoding="utf-8"?>
-<p:notes xmlns:a="http://schemas.openxmlformats.org/drawingml/2006/main" xmlns:r="http://schemas.openxmlformats.org/officeDocument/2006/relationships" xmlns:p="http://schemas.openxmlformats.org/presentationml/2006/main">
+<file path=ppt/notesSlides/notesSlide13.xml><?xml version="1.0" encoding="utf-8"?>
+<p:notes xmlns:a="http://schemas.openxmlformats.org/drawingml/2006/main" xmlns:p="http://schemas.openxmlformats.org/presentationml/2006/main" xmlns:r="http://schemas.openxmlformats.org/officeDocument/2006/relationships">
   <p:cSld>
     <p:spTree>
       <p:nvGrpSpPr>
@@ -758,7 +984,7 @@
         <p:nvSpPr>
           <p:cNvPr id="2" name="Slide Image Placeholder 1"/>
           <p:cNvSpPr>
-            <a:spLocks noGrp="1" noRot="1" noChangeAspect="1"/>
+            <a:spLocks noGrp="1"/>
           </p:cNvSpPr>
           <p:nvPr>
             <p:ph type="sldImg" idx="2"/>
@@ -773,7 +999,7 @@
             <a:spLocks noGrp="1"/>
           </p:cNvSpPr>
           <p:nvPr>
-            <p:ph type="body" sz="quarter" idx="3"/>
+            <p:ph type="body" idx="3" sz="quarter"/>
           </p:nvPr>
         </p:nvSpPr>
         <p:spPr/>
@@ -782,7 +1008,7 @@
           <a:lstStyle/>
           <a:p>
             <a:r>
-              <a:t>Set up the decision. The standard is external because WDFW has none for this fishery.</a:t>
+              <a:t>Two crews, not one, because Long Beach is far longer than Twin Harbors or Mocrocks and carries several thousand diggers on a good day. The paired northern survey is the explicit test of the imputation the whole program leans on.</a:t>
             </a:r>
           </a:p>
         </p:txBody>
@@ -794,7 +1020,7 @@
             <a:spLocks noGrp="1"/>
           </p:cNvSpPr>
           <p:nvPr>
-            <p:ph type="sldNum" sz="quarter" idx="5"/>
+            <p:ph type="sldNum" idx="5" sz="quarter"/>
           </p:nvPr>
         </p:nvSpPr>
         <p:spPr/>
@@ -807,8 +1033,8 @@
 </p:notes>
 </file>
 
-<file path=ppt/notesSlides/notesSlide3.xml><?xml version="1.0" encoding="utf-8"?>
-<p:notes xmlns:a="http://schemas.openxmlformats.org/drawingml/2006/main" xmlns:r="http://schemas.openxmlformats.org/officeDocument/2006/relationships" xmlns:p="http://schemas.openxmlformats.org/presentationml/2006/main">
+<file path=ppt/notesSlides/notesSlide14.xml><?xml version="1.0" encoding="utf-8"?>
+<p:notes xmlns:a="http://schemas.openxmlformats.org/drawingml/2006/main" xmlns:p="http://schemas.openxmlformats.org/presentationml/2006/main" xmlns:r="http://schemas.openxmlformats.org/officeDocument/2006/relationships">
   <p:cSld>
     <p:spTree>
       <p:nvGrpSpPr>
@@ -828,7 +1054,7 @@
         <p:nvSpPr>
           <p:cNvPr id="2" name="Slide Image Placeholder 1"/>
           <p:cNvSpPr>
-            <a:spLocks noGrp="1" noRot="1" noChangeAspect="1"/>
+            <a:spLocks noGrp="1"/>
           </p:cNvSpPr>
           <p:nvPr>
             <p:ph type="sldImg" idx="2"/>
@@ -843,7 +1069,7 @@
             <a:spLocks noGrp="1"/>
           </p:cNvSpPr>
           <p:nvPr>
-            <p:ph type="body" sz="quarter" idx="3"/>
+            <p:ph type="body" idx="3" sz="quarter"/>
           </p:nvPr>
         </p:nvSpPr>
         <p:spPr/>
@@ -852,7 +1078,7 @@
           <a:lstStyle/>
           <a:p>
             <a:r>
-              <a:t>Sec 6.2-6.3. The instrument itself changed, which propagates into the imputation ratios.</a:t>
+              <a:t>Sec 10.3 / new Fig 16. The pilot is not one survey but the start of a rebuilt table; and because it is whole-beach it fixes the within-beach section allocation that partial surveys leave imputed.</a:t>
             </a:r>
           </a:p>
         </p:txBody>
@@ -864,7 +1090,7 @@
             <a:spLocks noGrp="1"/>
           </p:cNvSpPr>
           <p:nvPr>
-            <p:ph type="sldNum" sz="quarter" idx="5"/>
+            <p:ph type="sldNum" idx="5" sz="quarter"/>
           </p:nvPr>
         </p:nvSpPr>
         <p:spPr/>
@@ -877,8 +1103,8 @@
 </p:notes>
 </file>
 
-<file path=ppt/notesSlides/notesSlide4.xml><?xml version="1.0" encoding="utf-8"?>
-<p:notes xmlns:a="http://schemas.openxmlformats.org/drawingml/2006/main" xmlns:r="http://schemas.openxmlformats.org/officeDocument/2006/relationships" xmlns:p="http://schemas.openxmlformats.org/presentationml/2006/main">
+<file path=ppt/notesSlides/notesSlide15.xml><?xml version="1.0" encoding="utf-8"?>
+<p:notes xmlns:a="http://schemas.openxmlformats.org/drawingml/2006/main" xmlns:p="http://schemas.openxmlformats.org/presentationml/2006/main" xmlns:r="http://schemas.openxmlformats.org/officeDocument/2006/relationships">
   <p:cSld>
     <p:spTree>
       <p:nvGrpSpPr>
@@ -898,7 +1124,7 @@
         <p:nvSpPr>
           <p:cNvPr id="2" name="Slide Image Placeholder 1"/>
           <p:cNvSpPr>
-            <a:spLocks noGrp="1" noRot="1" noChangeAspect="1"/>
+            <a:spLocks noGrp="1"/>
           </p:cNvSpPr>
           <p:nvPr>
             <p:ph type="sldImg" idx="2"/>
@@ -913,7 +1139,7 @@
             <a:spLocks noGrp="1"/>
           </p:cNvSpPr>
           <p:nvPr>
-            <p:ph type="body" sz="quarter" idx="3"/>
+            <p:ph type="body" idx="3" sz="quarter"/>
           </p:nvPr>
         </p:nvSpPr>
         <p:spPr/>
@@ -922,7 +1148,7 @@
           <a:lstStyle/>
           <a:p>
             <a:r>
-              <a:t>Sec 10.1 / Table 14. Key reframing: magnitude is not what matters, correlation is.</a:t>
+              <a:t>Reordered after the Quinault correction. #1 (the pilot) and #2 (hold the donor floor) are the highest-leverage moves. #4 replaces the old 'condition the pullback on tribal data-sharing', which was wrong: there is no tribal offset.</a:t>
             </a:r>
           </a:p>
         </p:txBody>
@@ -934,7 +1160,7 @@
             <a:spLocks noGrp="1"/>
           </p:cNvSpPr>
           <p:nvPr>
-            <p:ph type="sldNum" sz="quarter" idx="5"/>
+            <p:ph type="sldNum" idx="5" sz="quarter"/>
           </p:nvPr>
         </p:nvSpPr>
         <p:spPr/>
@@ -947,8 +1173,8 @@
 </p:notes>
 </file>
 
-<file path=ppt/notesSlides/notesSlide5.xml><?xml version="1.0" encoding="utf-8"?>
-<p:notes xmlns:a="http://schemas.openxmlformats.org/drawingml/2006/main" xmlns:r="http://schemas.openxmlformats.org/officeDocument/2006/relationships" xmlns:p="http://schemas.openxmlformats.org/presentationml/2006/main">
+<file path=ppt/notesSlides/notesSlide2.xml><?xml version="1.0" encoding="utf-8"?>
+<p:notes xmlns:a="http://schemas.openxmlformats.org/drawingml/2006/main" xmlns:p="http://schemas.openxmlformats.org/presentationml/2006/main" xmlns:r="http://schemas.openxmlformats.org/officeDocument/2006/relationships">
   <p:cSld>
     <p:spTree>
       <p:nvGrpSpPr>
@@ -968,7 +1194,7 @@
         <p:nvSpPr>
           <p:cNvPr id="2" name="Slide Image Placeholder 1"/>
           <p:cNvSpPr>
-            <a:spLocks noGrp="1" noRot="1" noChangeAspect="1"/>
+            <a:spLocks noGrp="1"/>
           </p:cNvSpPr>
           <p:nvPr>
             <p:ph type="sldImg" idx="2"/>
@@ -983,7 +1209,7 @@
             <a:spLocks noGrp="1"/>
           </p:cNvSpPr>
           <p:nvPr>
-            <p:ph type="body" sz="quarter" idx="3"/>
+            <p:ph type="body" idx="3" sz="quarter"/>
           </p:nvPr>
         </p:nvSpPr>
         <p:spPr/>
@@ -992,7 +1218,7 @@
           <a:lstStyle/>
           <a:p>
             <a:r>
-              <a:t>Sec 10.2 / Tables 15-16. Foreshadows the donor question: the southern beaches are the donors.</a:t>
+              <a:t>Set up the decision. The standard is external because WDFW has none for this fishery.</a:t>
             </a:r>
           </a:p>
         </p:txBody>
@@ -1004,7 +1230,7 @@
             <a:spLocks noGrp="1"/>
           </p:cNvSpPr>
           <p:nvPr>
-            <p:ph type="sldNum" sz="quarter" idx="5"/>
+            <p:ph type="sldNum" idx="5" sz="quarter"/>
           </p:nvPr>
         </p:nvSpPr>
         <p:spPr/>
@@ -1017,8 +1243,8 @@
 </p:notes>
 </file>
 
-<file path=ppt/notesSlides/notesSlide6.xml><?xml version="1.0" encoding="utf-8"?>
-<p:notes xmlns:a="http://schemas.openxmlformats.org/drawingml/2006/main" xmlns:r="http://schemas.openxmlformats.org/officeDocument/2006/relationships" xmlns:p="http://schemas.openxmlformats.org/presentationml/2006/main">
+<file path=ppt/notesSlides/notesSlide3.xml><?xml version="1.0" encoding="utf-8"?>
+<p:notes xmlns:a="http://schemas.openxmlformats.org/drawingml/2006/main" xmlns:p="http://schemas.openxmlformats.org/presentationml/2006/main" xmlns:r="http://schemas.openxmlformats.org/officeDocument/2006/relationships">
   <p:cSld>
     <p:spTree>
       <p:nvGrpSpPr>
@@ -1038,7 +1264,7 @@
         <p:nvSpPr>
           <p:cNvPr id="2" name="Slide Image Placeholder 1"/>
           <p:cNvSpPr>
-            <a:spLocks noGrp="1" noRot="1" noChangeAspect="1"/>
+            <a:spLocks noGrp="1"/>
           </p:cNvSpPr>
           <p:nvPr>
             <p:ph type="sldImg" idx="2"/>
@@ -1053,7 +1279,7 @@
             <a:spLocks noGrp="1"/>
           </p:cNvSpPr>
           <p:nvPr>
-            <p:ph type="body" sz="quarter" idx="3"/>
+            <p:ph type="body" idx="3" sz="quarter"/>
           </p:nvPr>
         </p:nvSpPr>
         <p:spPr/>
@@ -1062,7 +1288,7 @@
           <a:lstStyle/>
           <a:p>
             <a:r>
-              <a:t>Sec 11.2 / Table 19. The headline answer.</a:t>
+              <a:t>Sec 6.2-6.3. The instrument itself changed, which propagates into the imputation ratios.</a:t>
             </a:r>
           </a:p>
         </p:txBody>
@@ -1074,7 +1300,7 @@
             <a:spLocks noGrp="1"/>
           </p:cNvSpPr>
           <p:nvPr>
-            <p:ph type="sldNum" sz="quarter" idx="5"/>
+            <p:ph type="sldNum" idx="5" sz="quarter"/>
           </p:nvPr>
         </p:nvSpPr>
         <p:spPr/>
@@ -1087,8 +1313,8 @@
 </p:notes>
 </file>
 
-<file path=ppt/notesSlides/notesSlide7.xml><?xml version="1.0" encoding="utf-8"?>
-<p:notes xmlns:a="http://schemas.openxmlformats.org/drawingml/2006/main" xmlns:r="http://schemas.openxmlformats.org/officeDocument/2006/relationships" xmlns:p="http://schemas.openxmlformats.org/presentationml/2006/main">
+<file path=ppt/notesSlides/notesSlide4.xml><?xml version="1.0" encoding="utf-8"?>
+<p:notes xmlns:a="http://schemas.openxmlformats.org/drawingml/2006/main" xmlns:p="http://schemas.openxmlformats.org/presentationml/2006/main" xmlns:r="http://schemas.openxmlformats.org/officeDocument/2006/relationships">
   <p:cSld>
     <p:spTree>
       <p:nvGrpSpPr>
@@ -1108,7 +1334,7 @@
         <p:nvSpPr>
           <p:cNvPr id="2" name="Slide Image Placeholder 1"/>
           <p:cNvSpPr>
-            <a:spLocks noGrp="1" noRot="1" noChangeAspect="1"/>
+            <a:spLocks noGrp="1"/>
           </p:cNvSpPr>
           <p:nvPr>
             <p:ph type="sldImg" idx="2"/>
@@ -1123,7 +1349,7 @@
             <a:spLocks noGrp="1"/>
           </p:cNvSpPr>
           <p:nvPr>
-            <p:ph type="body" sz="quarter" idx="3"/>
+            <p:ph type="body" idx="3" sz="quarter"/>
           </p:nvPr>
         </p:nvSpPr>
         <p:spPr/>
@@ -1132,7 +1358,7 @@
           <a:lstStyle/>
           <a:p>
             <a:r>
-              <a:t>Sec 11.3 / Table 20.</a:t>
+              <a:t>Sec 10.1 / Table 14. Key reframing: magnitude is not what matters, correlation is.</a:t>
             </a:r>
           </a:p>
         </p:txBody>
@@ -1144,7 +1370,7 @@
             <a:spLocks noGrp="1"/>
           </p:cNvSpPr>
           <p:nvPr>
-            <p:ph type="sldNum" sz="quarter" idx="5"/>
+            <p:ph type="sldNum" idx="5" sz="quarter"/>
           </p:nvPr>
         </p:nvSpPr>
         <p:spPr/>
@@ -1157,8 +1383,8 @@
 </p:notes>
 </file>
 
-<file path=ppt/notesSlides/notesSlide8.xml><?xml version="1.0" encoding="utf-8"?>
-<p:notes xmlns:a="http://schemas.openxmlformats.org/drawingml/2006/main" xmlns:r="http://schemas.openxmlformats.org/officeDocument/2006/relationships" xmlns:p="http://schemas.openxmlformats.org/presentationml/2006/main">
+<file path=ppt/notesSlides/notesSlide5.xml><?xml version="1.0" encoding="utf-8"?>
+<p:notes xmlns:a="http://schemas.openxmlformats.org/drawingml/2006/main" xmlns:p="http://schemas.openxmlformats.org/presentationml/2006/main" xmlns:r="http://schemas.openxmlformats.org/officeDocument/2006/relationships">
   <p:cSld>
     <p:spTree>
       <p:nvGrpSpPr>
@@ -1178,7 +1404,7 @@
         <p:nvSpPr>
           <p:cNvPr id="2" name="Slide Image Placeholder 1"/>
           <p:cNvSpPr>
-            <a:spLocks noGrp="1" noRot="1" noChangeAspect="1"/>
+            <a:spLocks noGrp="1"/>
           </p:cNvSpPr>
           <p:nvPr>
             <p:ph type="sldImg" idx="2"/>
@@ -1193,7 +1419,7 @@
             <a:spLocks noGrp="1"/>
           </p:cNvSpPr>
           <p:nvPr>
-            <p:ph type="body" sz="quarter" idx="3"/>
+            <p:ph type="body" idx="3" sz="quarter"/>
           </p:nvPr>
         </p:nvSpPr>
         <p:spPr/>
@@ -1202,7 +1428,7 @@
           <a:lstStyle/>
           <a:p>
             <a:r>
-              <a:t>Sec 11.4 / Table 21. Only surveys move the floor.</a:t>
+              <a:t>Sec 10.2 / Tables 15-16. Foreshadows the donor question: the southern beaches are the donors.</a:t>
             </a:r>
           </a:p>
         </p:txBody>
@@ -1214,7 +1440,7 @@
             <a:spLocks noGrp="1"/>
           </p:cNvSpPr>
           <p:nvPr>
-            <p:ph type="sldNum" sz="quarter" idx="5"/>
+            <p:ph type="sldNum" idx="5" sz="quarter"/>
           </p:nvPr>
         </p:nvSpPr>
         <p:spPr/>
@@ -1227,8 +1453,8 @@
 </p:notes>
 </file>
 
-<file path=ppt/notesSlides/notesSlide9.xml><?xml version="1.0" encoding="utf-8"?>
-<p:notes xmlns:a="http://schemas.openxmlformats.org/drawingml/2006/main" xmlns:r="http://schemas.openxmlformats.org/officeDocument/2006/relationships" xmlns:p="http://schemas.openxmlformats.org/presentationml/2006/main">
+<file path=ppt/notesSlides/notesSlide6.xml><?xml version="1.0" encoding="utf-8"?>
+<p:notes xmlns:a="http://schemas.openxmlformats.org/drawingml/2006/main" xmlns:p="http://schemas.openxmlformats.org/presentationml/2006/main" xmlns:r="http://schemas.openxmlformats.org/officeDocument/2006/relationships">
   <p:cSld>
     <p:spTree>
       <p:nvGrpSpPr>
@@ -1248,7 +1474,7 @@
         <p:nvSpPr>
           <p:cNvPr id="2" name="Slide Image Placeholder 1"/>
           <p:cNvSpPr>
-            <a:spLocks noGrp="1" noRot="1" noChangeAspect="1"/>
+            <a:spLocks noGrp="1"/>
           </p:cNvSpPr>
           <p:nvPr>
             <p:ph type="sldImg" idx="2"/>
@@ -1263,7 +1489,7 @@
             <a:spLocks noGrp="1"/>
           </p:cNvSpPr>
           <p:nvPr>
-            <p:ph type="body" sz="quarter" idx="3"/>
+            <p:ph type="body" idx="3" sz="quarter"/>
           </p:nvPr>
         </p:nvSpPr>
         <p:spPr/>
@@ -1272,6 +1498,216 @@
           <a:lstStyle/>
           <a:p>
             <a:r>
+              <a:t>Sec 11.2 / Table 19. The headline answer.</a:t>
+            </a:r>
+          </a:p>
+        </p:txBody>
+      </p:sp>
+      <p:sp>
+        <p:nvSpPr>
+          <p:cNvPr id="4" name="Slide Number Placeholder 3"/>
+          <p:cNvSpPr>
+            <a:spLocks noGrp="1"/>
+          </p:cNvSpPr>
+          <p:nvPr>
+            <p:ph type="sldNum" idx="5" sz="quarter"/>
+          </p:nvPr>
+        </p:nvSpPr>
+        <p:spPr/>
+      </p:sp>
+    </p:spTree>
+  </p:cSld>
+  <p:clrMapOvr>
+    <a:masterClrMapping/>
+  </p:clrMapOvr>
+</p:notes>
+</file>
+
+<file path=ppt/notesSlides/notesSlide7.xml><?xml version="1.0" encoding="utf-8"?>
+<p:notes xmlns:a="http://schemas.openxmlformats.org/drawingml/2006/main" xmlns:p="http://schemas.openxmlformats.org/presentationml/2006/main" xmlns:r="http://schemas.openxmlformats.org/officeDocument/2006/relationships">
+  <p:cSld>
+    <p:spTree>
+      <p:nvGrpSpPr>
+        <p:cNvPr id="1" name=""/>
+        <p:cNvGrpSpPr/>
+        <p:nvPr/>
+      </p:nvGrpSpPr>
+      <p:grpSpPr>
+        <a:xfrm>
+          <a:off x="0" y="0"/>
+          <a:ext cx="0" cy="0"/>
+          <a:chOff x="0" y="0"/>
+          <a:chExt cx="0" cy="0"/>
+        </a:xfrm>
+      </p:grpSpPr>
+      <p:sp>
+        <p:nvSpPr>
+          <p:cNvPr id="2" name="Slide Image Placeholder 1"/>
+          <p:cNvSpPr>
+            <a:spLocks noGrp="1"/>
+          </p:cNvSpPr>
+          <p:nvPr>
+            <p:ph type="sldImg" idx="2"/>
+          </p:nvPr>
+        </p:nvSpPr>
+        <p:spPr/>
+      </p:sp>
+      <p:sp>
+        <p:nvSpPr>
+          <p:cNvPr id="3" name="Notes Placeholder 2"/>
+          <p:cNvSpPr>
+            <a:spLocks noGrp="1"/>
+          </p:cNvSpPr>
+          <p:nvPr>
+            <p:ph type="body" idx="3" sz="quarter"/>
+          </p:nvPr>
+        </p:nvSpPr>
+        <p:spPr/>
+        <p:txBody>
+          <a:bodyPr/>
+          <a:lstStyle/>
+          <a:p>
+            <a:r>
+              <a:t>Sec 11.3 / Table 20.</a:t>
+            </a:r>
+          </a:p>
+        </p:txBody>
+      </p:sp>
+      <p:sp>
+        <p:nvSpPr>
+          <p:cNvPr id="4" name="Slide Number Placeholder 3"/>
+          <p:cNvSpPr>
+            <a:spLocks noGrp="1"/>
+          </p:cNvSpPr>
+          <p:nvPr>
+            <p:ph type="sldNum" idx="5" sz="quarter"/>
+          </p:nvPr>
+        </p:nvSpPr>
+        <p:spPr/>
+      </p:sp>
+    </p:spTree>
+  </p:cSld>
+  <p:clrMapOvr>
+    <a:masterClrMapping/>
+  </p:clrMapOvr>
+</p:notes>
+</file>
+
+<file path=ppt/notesSlides/notesSlide8.xml><?xml version="1.0" encoding="utf-8"?>
+<p:notes xmlns:a="http://schemas.openxmlformats.org/drawingml/2006/main" xmlns:p="http://schemas.openxmlformats.org/presentationml/2006/main" xmlns:r="http://schemas.openxmlformats.org/officeDocument/2006/relationships">
+  <p:cSld>
+    <p:spTree>
+      <p:nvGrpSpPr>
+        <p:cNvPr id="1" name=""/>
+        <p:cNvGrpSpPr/>
+        <p:nvPr/>
+      </p:nvGrpSpPr>
+      <p:grpSpPr>
+        <a:xfrm>
+          <a:off x="0" y="0"/>
+          <a:ext cx="0" cy="0"/>
+          <a:chOff x="0" y="0"/>
+          <a:chExt cx="0" cy="0"/>
+        </a:xfrm>
+      </p:grpSpPr>
+      <p:sp>
+        <p:nvSpPr>
+          <p:cNvPr id="2" name="Slide Image Placeholder 1"/>
+          <p:cNvSpPr>
+            <a:spLocks noGrp="1"/>
+          </p:cNvSpPr>
+          <p:nvPr>
+            <p:ph type="sldImg" idx="2"/>
+          </p:nvPr>
+        </p:nvSpPr>
+        <p:spPr/>
+      </p:sp>
+      <p:sp>
+        <p:nvSpPr>
+          <p:cNvPr id="3" name="Notes Placeholder 2"/>
+          <p:cNvSpPr>
+            <a:spLocks noGrp="1"/>
+          </p:cNvSpPr>
+          <p:nvPr>
+            <p:ph type="body" idx="3" sz="quarter"/>
+          </p:nvPr>
+        </p:nvSpPr>
+        <p:spPr/>
+        <p:txBody>
+          <a:bodyPr/>
+          <a:lstStyle/>
+          <a:p>
+            <a:r>
+              <a:t>Sec 11.4 / Table 21. Only surveys move the floor.</a:t>
+            </a:r>
+          </a:p>
+        </p:txBody>
+      </p:sp>
+      <p:sp>
+        <p:nvSpPr>
+          <p:cNvPr id="4" name="Slide Number Placeholder 3"/>
+          <p:cNvSpPr>
+            <a:spLocks noGrp="1"/>
+          </p:cNvSpPr>
+          <p:nvPr>
+            <p:ph type="sldNum" idx="5" sz="quarter"/>
+          </p:nvPr>
+        </p:nvSpPr>
+        <p:spPr/>
+      </p:sp>
+    </p:spTree>
+  </p:cSld>
+  <p:clrMapOvr>
+    <a:masterClrMapping/>
+  </p:clrMapOvr>
+</p:notes>
+</file>
+
+<file path=ppt/notesSlides/notesSlide9.xml><?xml version="1.0" encoding="utf-8"?>
+<p:notes xmlns:a="http://schemas.openxmlformats.org/drawingml/2006/main" xmlns:p="http://schemas.openxmlformats.org/presentationml/2006/main" xmlns:r="http://schemas.openxmlformats.org/officeDocument/2006/relationships">
+  <p:cSld>
+    <p:spTree>
+      <p:nvGrpSpPr>
+        <p:cNvPr id="1" name=""/>
+        <p:cNvGrpSpPr/>
+        <p:nvPr/>
+      </p:nvGrpSpPr>
+      <p:grpSpPr>
+        <a:xfrm>
+          <a:off x="0" y="0"/>
+          <a:ext cx="0" cy="0"/>
+          <a:chOff x="0" y="0"/>
+          <a:chExt cx="0" cy="0"/>
+        </a:xfrm>
+      </p:grpSpPr>
+      <p:sp>
+        <p:nvSpPr>
+          <p:cNvPr id="2" name="Slide Image Placeholder 1"/>
+          <p:cNvSpPr>
+            <a:spLocks noGrp="1"/>
+          </p:cNvSpPr>
+          <p:nvPr>
+            <p:ph type="sldImg" idx="2"/>
+          </p:nvPr>
+        </p:nvSpPr>
+        <p:spPr/>
+      </p:sp>
+      <p:sp>
+        <p:nvSpPr>
+          <p:cNvPr id="3" name="Notes Placeholder 2"/>
+          <p:cNvSpPr>
+            <a:spLocks noGrp="1"/>
+          </p:cNvSpPr>
+          <p:nvPr>
+            <p:ph type="body" idx="3" sz="quarter"/>
+          </p:nvPr>
+        </p:nvSpPr>
+        <p:spPr/>
+        <p:txBody>
+          <a:bodyPr/>
+          <a:lstStyle/>
+          <a:p>
+            <a:r>
               <a:t>Sec 11.5 / Table 22. Cost-neutral. But see the donor caveat next.</a:t>
             </a:r>
           </a:p>
@@ -1284,7 +1720,7 @@
             <a:spLocks noGrp="1"/>
           </p:cNvSpPr>
           <p:nvPr>
-            <p:ph type="sldNum" sz="quarter" idx="5"/>
+            <p:ph type="sldNum" idx="5" sz="quarter"/>
           </p:nvPr>
         </p:nvSpPr>
         <p:spPr/>
@@ -1505,13 +1941,13 @@
           <p:nvPr userDrawn="1"/>
         </p:nvPicPr>
         <p:blipFill>
-          <a:blip>
+          <a:blip r:embed="rId2">
             <a:extLst>
               <a:ext uri="{28A0092B-C50C-407E-A947-70E740481C1C}">
                 <a14:useLocalDpi xmlns:a14="http://schemas.microsoft.com/office/drawing/2010/main" val="0"/>
               </a:ext>
               <a:ext uri="{96DAC541-7B7A-43D3-8B79-37D633B846F1}">
-                <asvg:svgBlip xmlns:asvg="http://schemas.microsoft.com/office/drawing/2016/SVG/main" r:embed="rId2"/>
+                <asvg:svgBlip xmlns:asvg="http://schemas.microsoft.com/office/drawing/2016/SVG/main" r:embed="rId3"/>
               </a:ext>
             </a:extLst>
           </a:blip>
@@ -2214,13 +2650,13 @@
           <p:nvPr userDrawn="1"/>
         </p:nvPicPr>
         <p:blipFill>
-          <a:blip>
+          <a:blip r:embed="rId2">
             <a:extLst>
               <a:ext uri="{28A0092B-C50C-407E-A947-70E740481C1C}">
                 <a14:useLocalDpi xmlns:a14="http://schemas.microsoft.com/office/drawing/2010/main" val="0"/>
               </a:ext>
               <a:ext uri="{96DAC541-7B7A-43D3-8B79-37D633B846F1}">
-                <asvg:svgBlip xmlns:asvg="http://schemas.microsoft.com/office/drawing/2016/SVG/main" r:embed="rId2"/>
+                <asvg:svgBlip xmlns:asvg="http://schemas.microsoft.com/office/drawing/2016/SVG/main" r:embed="rId3"/>
               </a:ext>
             </a:extLst>
           </a:blip>
@@ -2677,13 +3113,13 @@
           <p:nvPr userDrawn="1"/>
         </p:nvPicPr>
         <p:blipFill>
-          <a:blip>
+          <a:blip r:embed="rId2">
             <a:extLst>
               <a:ext uri="{28A0092B-C50C-407E-A947-70E740481C1C}">
                 <a14:useLocalDpi xmlns:a14="http://schemas.microsoft.com/office/drawing/2010/main" val="0"/>
               </a:ext>
               <a:ext uri="{96DAC541-7B7A-43D3-8B79-37D633B846F1}">
-                <asvg:svgBlip xmlns:asvg="http://schemas.microsoft.com/office/drawing/2016/SVG/main" r:embed="rId2"/>
+                <asvg:svgBlip xmlns:asvg="http://schemas.microsoft.com/office/drawing/2016/SVG/main" r:embed="rId3"/>
               </a:ext>
             </a:extLst>
           </a:blip>
@@ -3187,13 +3623,13 @@
           <p:nvPr userDrawn="1"/>
         </p:nvPicPr>
         <p:blipFill>
-          <a:blip>
+          <a:blip r:embed="rId2">
             <a:extLst>
               <a:ext uri="{28A0092B-C50C-407E-A947-70E740481C1C}">
                 <a14:useLocalDpi xmlns:a14="http://schemas.microsoft.com/office/drawing/2010/main" val="0"/>
               </a:ext>
               <a:ext uri="{96DAC541-7B7A-43D3-8B79-37D633B846F1}">
-                <asvg:svgBlip xmlns:asvg="http://schemas.microsoft.com/office/drawing/2016/SVG/main" r:embed="rId2"/>
+                <asvg:svgBlip xmlns:asvg="http://schemas.microsoft.com/office/drawing/2016/SVG/main" r:embed="rId3"/>
               </a:ext>
             </a:extLst>
           </a:blip>
@@ -3801,13 +4237,13 @@
           <p:nvPr userDrawn="1"/>
         </p:nvPicPr>
         <p:blipFill>
-          <a:blip>
+          <a:blip r:embed="rId2">
             <a:extLst>
               <a:ext uri="{28A0092B-C50C-407E-A947-70E740481C1C}">
                 <a14:useLocalDpi xmlns:a14="http://schemas.microsoft.com/office/drawing/2010/main" val="0"/>
               </a:ext>
               <a:ext uri="{96DAC541-7B7A-43D3-8B79-37D633B846F1}">
-                <asvg:svgBlip xmlns:asvg="http://schemas.microsoft.com/office/drawing/2016/SVG/main" r:embed="rId2"/>
+                <asvg:svgBlip xmlns:asvg="http://schemas.microsoft.com/office/drawing/2016/SVG/main" r:embed="rId3"/>
               </a:ext>
             </a:extLst>
           </a:blip>
@@ -4537,13 +4973,13 @@
           <p:nvPr userDrawn="1"/>
         </p:nvPicPr>
         <p:blipFill>
-          <a:blip>
+          <a:blip r:embed="rId2">
             <a:extLst>
               <a:ext uri="{28A0092B-C50C-407E-A947-70E740481C1C}">
                 <a14:useLocalDpi xmlns:a14="http://schemas.microsoft.com/office/drawing/2010/main" val="0"/>
               </a:ext>
               <a:ext uri="{96DAC541-7B7A-43D3-8B79-37D633B846F1}">
-                <asvg:svgBlip xmlns:asvg="http://schemas.microsoft.com/office/drawing/2016/SVG/main" r:embed="rId2"/>
+                <asvg:svgBlip xmlns:asvg="http://schemas.microsoft.com/office/drawing/2016/SVG/main" r:embed="rId3"/>
               </a:ext>
             </a:extLst>
           </a:blip>
@@ -5395,13 +5831,13 @@
           <p:nvPr userDrawn="1"/>
         </p:nvPicPr>
         <p:blipFill>
-          <a:blip>
+          <a:blip r:embed="rId2">
             <a:extLst>
               <a:ext uri="{28A0092B-C50C-407E-A947-70E740481C1C}">
                 <a14:useLocalDpi xmlns:a14="http://schemas.microsoft.com/office/drawing/2010/main" val="0"/>
               </a:ext>
               <a:ext uri="{96DAC541-7B7A-43D3-8B79-37D633B846F1}">
-                <asvg:svgBlip xmlns:asvg="http://schemas.microsoft.com/office/drawing/2016/SVG/main" r:embed="rId2"/>
+                <asvg:svgBlip xmlns:asvg="http://schemas.microsoft.com/office/drawing/2016/SVG/main" r:embed="rId3"/>
               </a:ext>
             </a:extLst>
           </a:blip>
@@ -5814,13 +6250,13 @@
           <p:nvPr userDrawn="1"/>
         </p:nvPicPr>
         <p:blipFill>
-          <a:blip>
+          <a:blip r:embed="rId2">
             <a:extLst>
               <a:ext uri="{28A0092B-C50C-407E-A947-70E740481C1C}">
                 <a14:useLocalDpi xmlns:a14="http://schemas.microsoft.com/office/drawing/2010/main" val="0"/>
               </a:ext>
               <a:ext uri="{96DAC541-7B7A-43D3-8B79-37D633B846F1}">
-                <asvg:svgBlip xmlns:asvg="http://schemas.microsoft.com/office/drawing/2016/SVG/main" r:embed="rId2"/>
+                <asvg:svgBlip xmlns:asvg="http://schemas.microsoft.com/office/drawing/2016/SVG/main" r:embed="rId3"/>
               </a:ext>
             </a:extLst>
           </a:blip>
@@ -6281,7 +6717,7 @@
 </file>
 
 <file path=ppt/slides/slide1.xml><?xml version="1.0" encoding="utf-8"?>
-<p:sld xmlns:a="http://schemas.openxmlformats.org/drawingml/2006/main" xmlns:r="http://schemas.openxmlformats.org/officeDocument/2006/relationships" xmlns:p="http://schemas.openxmlformats.org/presentationml/2006/main">
+<p:sld xmlns:a="http://schemas.openxmlformats.org/drawingml/2006/main" xmlns:p="http://schemas.openxmlformats.org/presentationml/2006/main" xmlns:r="http://schemas.openxmlformats.org/officeDocument/2006/relationships">
   <p:cSld>
     <p:spTree>
       <p:nvGrpSpPr>
@@ -6289,14 +6725,7 @@
         <p:cNvGrpSpPr/>
         <p:nvPr/>
       </p:nvGrpSpPr>
-      <p:grpSpPr>
-        <a:xfrm>
-          <a:off x="0" y="0"/>
-          <a:ext cx="0" cy="0"/>
-          <a:chOff x="0" y="0"/>
-          <a:chExt cx="0" cy="0"/>
-        </a:xfrm>
-      </p:grpSpPr>
+      <p:grpSpPr/>
       <p:sp>
         <p:nvSpPr>
           <p:cNvPr id="2" name="Title 1"/>
@@ -6325,30 +6754,25 @@
             <a:spLocks noGrp="1"/>
           </p:cNvSpPr>
           <p:nvPr>
-            <p:ph sz="half" idx="1"/>
+            <p:ph idx="1" sz="half"/>
           </p:nvPr>
         </p:nvSpPr>
         <p:spPr/>
         <p:txBody>
-          <a:bodyPr wrap="square">
-            <a:noAutofit/>
-          </a:bodyPr>
+          <a:bodyPr wrap="square"/>
           <a:lstStyle/>
           <a:p>
             <a:r>
-              <a:rPr sz="2000" dirty="0"/>
               <a:t>Findings from the 2026 harvest-estimate methodology review (v10)</a:t>
             </a:r>
           </a:p>
           <a:p>
             <a:r>
-              <a:rPr sz="2000" dirty="0"/>
               <a:t>Matthew George  ·  Coastal Shellfish Unit, WDFW</a:t>
             </a:r>
           </a:p>
           <a:p>
             <a:r>
-              <a:rPr sz="2000" dirty="0"/>
               <a:t>2026-27 season planning</a:t>
             </a:r>
           </a:p>
@@ -6363,7 +6787,7 @@
 </file>
 
 <file path=ppt/slides/slide10.xml><?xml version="1.0" encoding="utf-8"?>
-<p:sld xmlns:a="http://schemas.openxmlformats.org/drawingml/2006/main" xmlns:r="http://schemas.openxmlformats.org/officeDocument/2006/relationships" xmlns:p="http://schemas.openxmlformats.org/presentationml/2006/main">
+<p:sld xmlns:a="http://schemas.openxmlformats.org/drawingml/2006/main" xmlns:p="http://schemas.openxmlformats.org/presentationml/2006/main" xmlns:r="http://schemas.openxmlformats.org/officeDocument/2006/relationships">
   <p:cSld>
     <p:spTree>
       <p:nvGrpSpPr>
@@ -6371,14 +6795,7 @@
         <p:cNvGrpSpPr/>
         <p:nvPr/>
       </p:nvGrpSpPr>
-      <p:grpSpPr>
-        <a:xfrm>
-          <a:off x="0" y="0"/>
-          <a:ext cx="0" cy="0"/>
-          <a:chOff x="0" y="0"/>
-          <a:chExt cx="0" cy="0"/>
-        </a:xfrm>
-      </p:grpSpPr>
+      <p:grpSpPr/>
       <p:sp>
         <p:nvSpPr>
           <p:cNvPr id="2" name="Title 1"/>
@@ -6407,7 +6824,7 @@
             <a:spLocks noGrp="1"/>
           </p:cNvSpPr>
           <p:nvPr>
-            <p:ph sz="half" idx="1"/>
+            <p:ph idx="1" sz="half"/>
           </p:nvPr>
         </p:nvSpPr>
         <p:spPr/>
@@ -6416,7 +6833,7 @@
           <a:lstStyle/>
           <a:p>
             <a:r>
-              <a:rPr sz="1500" b="1"/>
+              <a:rPr b="1" sz="1500"/>
               <a:t>Copalis cannot go below a series CV of 0.126; Mocrocks below 0.095 </a:t>
             </a:r>
             <a:r>
@@ -6432,7 +6849,7 @@
           </a:p>
           <a:p>
             <a:r>
-              <a:rPr sz="1500" b="1"/>
+              <a:rPr b="1" sz="1500"/>
               <a:t>The question inverts: </a:t>
             </a:r>
             <a:r>
@@ -6449,16 +6866,14 @@
             <a:spLocks noGrp="1"/>
           </p:cNvSpPr>
           <p:nvPr>
-            <p:ph sz="half" idx="11"/>
+            <p:ph idx="11" sz="half"/>
           </p:nvPr>
         </p:nvSpPr>
         <p:spPr/>
         <p:txBody>
           <a:bodyPr/>
           <a:lstStyle/>
-          <a:p>
-            <a:endParaRPr/>
-          </a:p>
+          <a:p/>
         </p:txBody>
       </p:sp>
       <p:pic>
@@ -6470,7 +6885,7 @@
           <p:nvPr/>
         </p:nvPicPr>
         <p:blipFill>
-          <a:blip r:embed="rId3"/>
+          <a:blip r:embed="rId2"/>
           <a:stretch>
             <a:fillRect/>
           </a:stretch>
@@ -6494,7 +6909,7 @@
 </file>
 
 <file path=ppt/slides/slide11.xml><?xml version="1.0" encoding="utf-8"?>
-<p:sld xmlns:a="http://schemas.openxmlformats.org/drawingml/2006/main" xmlns:r="http://schemas.openxmlformats.org/officeDocument/2006/relationships" xmlns:p="http://schemas.openxmlformats.org/presentationml/2006/main">
+<p:sld xmlns:a="http://schemas.openxmlformats.org/drawingml/2006/main" xmlns:p="http://schemas.openxmlformats.org/presentationml/2006/main" xmlns:r="http://schemas.openxmlformats.org/officeDocument/2006/relationships">
   <p:cSld>
     <p:spTree>
       <p:nvGrpSpPr>
@@ -6502,14 +6917,7 @@
         <p:cNvGrpSpPr/>
         <p:nvPr/>
       </p:nvGrpSpPr>
-      <p:grpSpPr>
-        <a:xfrm>
-          <a:off x="0" y="0"/>
-          <a:ext cx="0" cy="0"/>
-          <a:chOff x="0" y="0"/>
-          <a:chExt cx="0" cy="0"/>
-        </a:xfrm>
-      </p:grpSpPr>
+      <p:grpSpPr/>
       <p:sp>
         <p:nvSpPr>
           <p:cNvPr id="2" name="Title 1"/>
@@ -6545,9 +6953,7 @@
         <p:txBody>
           <a:bodyPr/>
           <a:lstStyle/>
-          <a:p>
-            <a:endParaRPr/>
-          </a:p>
+          <a:p/>
         </p:txBody>
       </p:sp>
       <p:graphicFrame>
@@ -6569,48 +6975,12 @@
                 <a:tableStyleId>{5C22544A-7EE6-4342-B048-85BDC9FD1C3A}</a:tableStyleId>
               </a:tblPr>
               <a:tblGrid>
-                <a:gridCol w="2560320">
-                  <a:extLst>
-                    <a:ext uri="{9D8B030D-6E8A-4147-A177-3AD203B41FA5}">
-                      <a16:colId xmlns:a16="http://schemas.microsoft.com/office/drawing/2014/main" val="20000"/>
-                    </a:ext>
-                  </a:extLst>
-                </a:gridCol>
-                <a:gridCol w="1463040">
-                  <a:extLst>
-                    <a:ext uri="{9D8B030D-6E8A-4147-A177-3AD203B41FA5}">
-                      <a16:colId xmlns:a16="http://schemas.microsoft.com/office/drawing/2014/main" val="20001"/>
-                    </a:ext>
-                  </a:extLst>
-                </a:gridCol>
-                <a:gridCol w="1920240">
-                  <a:extLst>
-                    <a:ext uri="{9D8B030D-6E8A-4147-A177-3AD203B41FA5}">
-                      <a16:colId xmlns:a16="http://schemas.microsoft.com/office/drawing/2014/main" val="20002"/>
-                    </a:ext>
-                  </a:extLst>
-                </a:gridCol>
-                <a:gridCol w="1280160">
-                  <a:extLst>
-                    <a:ext uri="{9D8B030D-6E8A-4147-A177-3AD203B41FA5}">
-                      <a16:colId xmlns:a16="http://schemas.microsoft.com/office/drawing/2014/main" val="20003"/>
-                    </a:ext>
-                  </a:extLst>
-                </a:gridCol>
-                <a:gridCol w="1874519">
-                  <a:extLst>
-                    <a:ext uri="{9D8B030D-6E8A-4147-A177-3AD203B41FA5}">
-                      <a16:colId xmlns:a16="http://schemas.microsoft.com/office/drawing/2014/main" val="20004"/>
-                    </a:ext>
-                  </a:extLst>
-                </a:gridCol>
-                <a:gridCol w="1874519">
-                  <a:extLst>
-                    <a:ext uri="{9D8B030D-6E8A-4147-A177-3AD203B41FA5}">
-                      <a16:colId xmlns:a16="http://schemas.microsoft.com/office/drawing/2014/main" val="20005"/>
-                    </a:ext>
-                  </a:extLst>
-                </a:gridCol>
+                <a:gridCol w="2560320"/>
+                <a:gridCol w="1463040"/>
+                <a:gridCol w="1920240"/>
+                <a:gridCol w="1280160"/>
+                <a:gridCol w="1874519"/>
+                <a:gridCol w="1874519"/>
               </a:tblGrid>
               <a:tr h="487680">
                 <a:tc>
@@ -6739,11 +7109,6 @@
                     </a:solidFill>
                   </a:tcPr>
                 </a:tc>
-                <a:extLst>
-                  <a:ext uri="{0D108BD9-81ED-4DB2-BD59-A6C34878D82A}">
-                    <a16:rowId xmlns:a16="http://schemas.microsoft.com/office/drawing/2014/main" val="10000"/>
-                  </a:ext>
-                </a:extLst>
               </a:tr>
               <a:tr h="487680">
                 <a:tc>
@@ -6824,11 +7189,6 @@
                   </a:txBody>
                   <a:tcPr/>
                 </a:tc>
-                <a:extLst>
-                  <a:ext uri="{0D108BD9-81ED-4DB2-BD59-A6C34878D82A}">
-                    <a16:rowId xmlns:a16="http://schemas.microsoft.com/office/drawing/2014/main" val="10001"/>
-                  </a:ext>
-                </a:extLst>
               </a:tr>
               <a:tr h="487680">
                 <a:tc>
@@ -6909,11 +7269,6 @@
                   </a:txBody>
                   <a:tcPr/>
                 </a:tc>
-                <a:extLst>
-                  <a:ext uri="{0D108BD9-81ED-4DB2-BD59-A6C34878D82A}">
-                    <a16:rowId xmlns:a16="http://schemas.microsoft.com/office/drawing/2014/main" val="10002"/>
-                  </a:ext>
-                </a:extLst>
               </a:tr>
               <a:tr h="487680">
                 <a:tc>
@@ -6994,11 +7349,6 @@
                   </a:txBody>
                   <a:tcPr/>
                 </a:tc>
-                <a:extLst>
-                  <a:ext uri="{0D108BD9-81ED-4DB2-BD59-A6C34878D82A}">
-                    <a16:rowId xmlns:a16="http://schemas.microsoft.com/office/drawing/2014/main" val="10003"/>
-                  </a:ext>
-                </a:extLst>
               </a:tr>
               <a:tr h="487680">
                 <a:tc>
@@ -7079,11 +7429,6 @@
                   </a:txBody>
                   <a:tcPr/>
                 </a:tc>
-                <a:extLst>
-                  <a:ext uri="{0D108BD9-81ED-4DB2-BD59-A6C34878D82A}">
-                    <a16:rowId xmlns:a16="http://schemas.microsoft.com/office/drawing/2014/main" val="10004"/>
-                  </a:ext>
-                </a:extLst>
               </a:tr>
               <a:tr h="487680">
                 <a:tc>
@@ -7103,9 +7448,7 @@
                   <a:txBody>
                     <a:bodyPr/>
                     <a:lstStyle/>
-                    <a:p>
-                      <a:endParaRPr/>
-                    </a:p>
+                    <a:p/>
                   </a:txBody>
                   <a:tcPr/>
                 </a:tc>
@@ -7139,9 +7482,7 @@
                   <a:txBody>
                     <a:bodyPr/>
                     <a:lstStyle/>
-                    <a:p>
-                      <a:endParaRPr/>
-                    </a:p>
+                    <a:p/>
                   </a:txBody>
                   <a:tcPr/>
                 </a:tc>
@@ -7158,11 +7499,6 @@
                   </a:txBody>
                   <a:tcPr/>
                 </a:tc>
-                <a:extLst>
-                  <a:ext uri="{0D108BD9-81ED-4DB2-BD59-A6C34878D82A}">
-                    <a16:rowId xmlns:a16="http://schemas.microsoft.com/office/drawing/2014/main" val="10005"/>
-                  </a:ext>
-                </a:extLst>
               </a:tr>
             </a:tbl>
           </a:graphicData>
@@ -7192,7 +7528,7 @@
           <a:p>
             <a:r>
               <a:rPr sz="1400"/>
-              <a:t>Long Beach's series CV falls from 0.294 to 0.175, crossing the design target for the first time. Copalis and Mocrocks rise to 0.192 and 0.171 and stay inside it. No new staff, nineteen surplus crew-day units on the two northern beaches move to Long Beach.</a:t>
+              <a:t>Long Beach's series CV falls from 0.294 to 0.175, crossing the design target for the first time. Copalis and Mocrocks rise to 0.192 and 0.171 and stay inside it. No new staff, nineteen crew-day units move to Long Beach; but those units are not truly free once the two beaches' donor role is counted, which the co-management slide takes up.</a:t>
             </a:r>
           </a:p>
         </p:txBody>
@@ -7206,7 +7542,7 @@
 </file>
 
 <file path=ppt/slides/slide12.xml><?xml version="1.0" encoding="utf-8"?>
-<p:sld xmlns:a="http://schemas.openxmlformats.org/drawingml/2006/main" xmlns:r="http://schemas.openxmlformats.org/officeDocument/2006/relationships" xmlns:p="http://schemas.openxmlformats.org/presentationml/2006/main">
+<p:sld xmlns:a="http://schemas.openxmlformats.org/drawingml/2006/main" xmlns:p="http://schemas.openxmlformats.org/presentationml/2006/main" xmlns:r="http://schemas.openxmlformats.org/officeDocument/2006/relationships">
   <p:cSld>
     <p:spTree>
       <p:nvGrpSpPr>
@@ -7214,14 +7550,7 @@
         <p:cNvGrpSpPr/>
         <p:nvPr/>
       </p:nvGrpSpPr>
-      <p:grpSpPr>
-        <a:xfrm>
-          <a:off x="0" y="0"/>
-          <a:ext cx="0" cy="0"/>
-          <a:chOff x="0" y="0"/>
-          <a:chExt cx="0" cy="0"/>
-        </a:xfrm>
-      </p:grpSpPr>
+      <p:grpSpPr/>
       <p:sp>
         <p:nvSpPr>
           <p:cNvPr id="2" name="Title 1"/>
@@ -7252,7 +7581,7 @@
 </file>
 
 <file path=ppt/slides/slide13.xml><?xml version="1.0" encoding="utf-8"?>
-<p:sld xmlns:a="http://schemas.openxmlformats.org/drawingml/2006/main" xmlns:r="http://schemas.openxmlformats.org/officeDocument/2006/relationships" xmlns:p="http://schemas.openxmlformats.org/presentationml/2006/main">
+<p:sld xmlns:a="http://schemas.openxmlformats.org/drawingml/2006/main" xmlns:p="http://schemas.openxmlformats.org/presentationml/2006/main" xmlns:r="http://schemas.openxmlformats.org/officeDocument/2006/relationships">
   <p:cSld>
     <p:spTree>
       <p:nvGrpSpPr>
@@ -7260,14 +7589,7 @@
         <p:cNvGrpSpPr/>
         <p:nvPr/>
       </p:nvGrpSpPr>
-      <p:grpSpPr>
-        <a:xfrm>
-          <a:off x="0" y="0"/>
-          <a:ext cx="0" cy="0"/>
-          <a:chOff x="0" y="0"/>
-          <a:chExt cx="0" cy="0"/>
-        </a:xfrm>
-      </p:grpSpPr>
+      <p:grpSpPr/>
       <p:sp>
         <p:nvSpPr>
           <p:cNvPr id="2" name="Title 1"/>
@@ -7296,7 +7618,7 @@
             <a:spLocks noGrp="1"/>
           </p:cNvSpPr>
           <p:nvPr>
-            <p:ph sz="half" idx="1"/>
+            <p:ph idx="1" sz="half"/>
           </p:nvPr>
         </p:nvSpPr>
         <p:spPr/>
@@ -7311,7 +7633,7 @@
           </a:p>
           <a:p>
             <a:r>
-              <a:rPr sz="1500" b="1"/>
+              <a:rPr b="1" sz="1500"/>
               <a:t>Newest survey: 2011. </a:t>
             </a:r>
             <a:r>
@@ -7327,7 +7649,7 @@
           </a:p>
           <a:p>
             <a:r>
-              <a:rPr sz="1500" b="1"/>
+              <a:rPr b="1" sz="1500"/>
               <a:t>The single most valuable unpurchased input </a:t>
             </a:r>
             <a:r>
@@ -7344,16 +7666,14 @@
             <a:spLocks noGrp="1"/>
           </p:cNvSpPr>
           <p:nvPr>
-            <p:ph sz="half" idx="11"/>
+            <p:ph idx="11" sz="half"/>
           </p:nvPr>
         </p:nvSpPr>
         <p:spPr/>
         <p:txBody>
           <a:bodyPr/>
           <a:lstStyle/>
-          <a:p>
-            <a:endParaRPr/>
-          </a:p>
+          <a:p/>
         </p:txBody>
       </p:sp>
       <p:pic>
@@ -7365,7 +7685,7 @@
           <p:nvPr/>
         </p:nvPicPr>
         <p:blipFill>
-          <a:blip r:embed="rId3"/>
+          <a:blip r:embed="rId2"/>
           <a:stretch>
             <a:fillRect/>
           </a:stretch>
@@ -7389,7 +7709,7 @@
 </file>
 
 <file path=ppt/slides/slide14.xml><?xml version="1.0" encoding="utf-8"?>
-<p:sld xmlns:a="http://schemas.openxmlformats.org/drawingml/2006/main" xmlns:r="http://schemas.openxmlformats.org/officeDocument/2006/relationships" xmlns:p="http://schemas.openxmlformats.org/presentationml/2006/main">
+<p:sld xmlns:a="http://schemas.openxmlformats.org/drawingml/2006/main" xmlns:p="http://schemas.openxmlformats.org/presentationml/2006/main" xmlns:r="http://schemas.openxmlformats.org/officeDocument/2006/relationships">
   <p:cSld>
     <p:spTree>
       <p:nvGrpSpPr>
@@ -7397,14 +7717,7 @@
         <p:cNvGrpSpPr/>
         <p:nvPr/>
       </p:nvGrpSpPr>
-      <p:grpSpPr>
-        <a:xfrm>
-          <a:off x="0" y="0"/>
-          <a:ext cx="0" cy="0"/>
-          <a:chOff x="0" y="0"/>
-          <a:chExt cx="0" cy="0"/>
-        </a:xfrm>
-      </p:grpSpPr>
+      <p:grpSpPr/>
       <p:sp>
         <p:nvSpPr>
           <p:cNvPr id="2" name="Title 1"/>
@@ -7421,7 +7734,7 @@
           <a:lstStyle/>
           <a:p>
             <a:r>
-              <a:t>Pulling the southern beaches back is not free, co-management is the lever</a:t>
+              <a:t>Pulling the southern beaches back is not free, and no tribal count offsets it</a:t>
             </a:r>
           </a:p>
         </p:txBody>
@@ -7433,7 +7746,7 @@
             <a:spLocks noGrp="1"/>
           </p:cNvSpPr>
           <p:nvPr>
-            <p:ph sz="half" idx="1"/>
+            <p:ph idx="1" sz="half"/>
           </p:nvPr>
         </p:nvSpPr>
         <p:spPr/>
@@ -7442,38 +7755,42 @@
           <a:lstStyle/>
           <a:p>
             <a:r>
-              <a:rPr sz="1400" b="1"/>
+              <a:rPr b="1" sz="1400"/>
               <a:t>Copalis and Mocrocks are the donor for ~63% </a:t>
             </a:r>
             <a:r>
               <a:rPr sz="1400"/>
-              <a:t>of Long Beach / Twin Harbors imputed days.</a:t>
-            </a:r>
-          </a:p>
-          <a:p>
+              <a:t>of Long Beach / Twin Harbors imputed days; jointly they are the best donor (sd 0.43 in log, against 0.62 and 0.64 for either alone).</a:t>
+            </a:r>
+          </a:p>
+          <a:p>
+            <a:r>
+              <a:rPr b="1" sz="1400"/>
+              <a:t>Under state-Quinault day-trading (2 on, 2 off) </a:t>
+            </a:r>
             <a:r>
               <a:rPr sz="1400"/>
-              <a:t>Under state-Quinault day-trading (2 on, 2 off) the two interleave: exactly one is state-counted each dig day.</a:t>
-            </a:r>
-          </a:p>
-          <a:p>
-            <a:r>
-              <a:rPr sz="1400" b="1"/>
-              <a:t>Pull state sampling to 45% </a:t>
+              <a:t>exactly one of the two is state-counted each dig day, so the state seldom holds that best joint donor.</a:t>
+            </a:r>
+          </a:p>
+          <a:p>
+            <a:r>
+              <a:rPr b="1" sz="1400"/>
+              <a:t>The Quinault dig the alternate days, </a:t>
             </a:r>
             <a:r>
               <a:rPr sz="1400"/>
-              <a:t>and single-day imputation error rises 0.45 → 0.50 (donor coverage 99% → 45%).</a:t>
-            </a:r>
-          </a:p>
-          <a:p>
-            <a:r>
-              <a:rPr sz="1400" b="1"/>
-              <a:t>Share the tribe's alternate-day counts </a:t>
+              <a:t>but theirs is a smaller, lower-participation fishery: its effort and catch rate do not proxy the state, so those counts cannot fill the state donor series.</a:t>
+            </a:r>
+          </a:p>
+          <a:p>
+            <a:r>
+              <a:rPr b="1" sz="1400"/>
+              <a:t>Pulling state sampling to 45% </a:t>
             </a:r>
             <a:r>
               <a:rPr sz="1400"/>
-              <a:t>and it holds at 0.40, better than today (both beaches every dig day = best joint donor).</a:t>
+              <a:t>raises single-day imputation error from 0.45 to 0.50 in the log, with no data-share available to offset it.</a:t>
             </a:r>
           </a:p>
         </p:txBody>
@@ -7485,16 +7802,14 @@
             <a:spLocks noGrp="1"/>
           </p:cNvSpPr>
           <p:nvPr>
-            <p:ph sz="half" idx="11"/>
+            <p:ph idx="11" sz="half"/>
           </p:nvPr>
         </p:nvSpPr>
         <p:spPr/>
         <p:txBody>
           <a:bodyPr/>
           <a:lstStyle/>
-          <a:p>
-            <a:endParaRPr/>
-          </a:p>
+          <a:p/>
         </p:txBody>
       </p:sp>
       <p:pic>
@@ -7506,7 +7821,7 @@
           <p:nvPr/>
         </p:nvPicPr>
         <p:blipFill>
-          <a:blip r:embed="rId3"/>
+          <a:blip r:embed="rId2"/>
           <a:stretch>
             <a:fillRect/>
           </a:stretch>
@@ -7530,7 +7845,7 @@
 </file>
 
 <file path=ppt/slides/slide15.xml><?xml version="1.0" encoding="utf-8"?>
-<p:sld xmlns:a="http://schemas.openxmlformats.org/drawingml/2006/main" xmlns:r="http://schemas.openxmlformats.org/officeDocument/2006/relationships" xmlns:p="http://schemas.openxmlformats.org/presentationml/2006/main">
+<p:sld xmlns:a="http://schemas.openxmlformats.org/drawingml/2006/main" xmlns:p="http://schemas.openxmlformats.org/presentationml/2006/main" xmlns:r="http://schemas.openxmlformats.org/officeDocument/2006/relationships">
   <p:cSld>
     <p:spTree>
       <p:nvGrpSpPr>
@@ -7538,14 +7853,7 @@
         <p:cNvGrpSpPr/>
         <p:nvPr/>
       </p:nvGrpSpPr>
-      <p:grpSpPr>
-        <a:xfrm>
-          <a:off x="0" y="0"/>
-          <a:ext cx="0" cy="0"/>
-          <a:chOff x="0" y="0"/>
-          <a:chExt cx="0" cy="0"/>
-        </a:xfrm>
-      </p:grpSpPr>
+      <p:grpSpPr/>
       <p:sp>
         <p:nvSpPr>
           <p:cNvPr id="2" name="Title 1"/>
@@ -7553,7 +7861,7 @@
             <a:spLocks noGrp="1"/>
           </p:cNvSpPr>
           <p:nvPr>
-            <p:ph type="title"/>
+            <p:ph type="ctrTitle"/>
           </p:nvPr>
         </p:nvSpPr>
         <p:spPr/>
@@ -7562,63 +7870,7 @@
           <a:lstStyle/>
           <a:p>
             <a:r>
-              <a:t>Recommendations, in priority order</a:t>
-            </a:r>
-          </a:p>
-        </p:txBody>
-      </p:sp>
-      <p:sp>
-        <p:nvSpPr>
-          <p:cNvPr id="3" name="Content Placeholder 2"/>
-          <p:cNvSpPr>
-            <a:spLocks noGrp="1"/>
-          </p:cNvSpPr>
-          <p:nvPr>
-            <p:ph idx="1"/>
-          </p:nvPr>
-        </p:nvSpPr>
-        <p:spPr/>
-        <p:txBody>
-          <a:bodyPr wrap="square"/>
-          <a:lstStyle/>
-          <a:p>
-            <a:r>
-              <a:rPr sz="1500" b="1"/>
-              <a:t>1.  Survey first. </a:t>
-            </a:r>
-            <a:r>
-              <a:rPr sz="1500"/>
-              <a:t>Run egress surveys at Long Beach and Twin Harbors, both conditions, the only input that moves the dominant term.</a:t>
-            </a:r>
-          </a:p>
-          <a:p>
-            <a:r>
-              <a:rPr sz="1500" b="1"/>
-              <a:t>2.  Sample ~45% of open days, largest-effort first, </a:t>
-            </a:r>
-            <a:r>
-              <a:rPr sz="1500"/>
-              <a:t>and reallocate crew from Copalis/Mocrocks to Long Beach. Cost-neutral (−19 crew-day units); Long Beach meets a published standard for the first time.</a:t>
-            </a:r>
-          </a:p>
-          <a:p>
-            <a:r>
-              <a:rPr sz="1500" b="1"/>
-              <a:t>3.  Condition the southern pullback on Quinault data-sharing </a:t>
-            </a:r>
-            <a:r>
-              <a:rPr sz="1500"/>
-              <a:t>for alternate-day effort and CPUE. It completes the donor series and holds northern-beach imputation error at or below today's.</a:t>
-            </a:r>
-          </a:p>
-          <a:p>
-            <a:r>
-              <a:rPr sz="1500" b="1"/>
-              <a:t>4.  Accept the Copalis floor: </a:t>
-            </a:r>
-            <a:r>
-              <a:rPr sz="1500"/>
-              <a:t>a harvest CV of 0.10 is infeasible there at any sampling rate, only more surveys would move it.</a:t>
+              <a:t>A Long Beach ingress / egress pilot</a:t>
             </a:r>
           </a:p>
         </p:txBody>
@@ -7632,7 +7884,7 @@
 </file>
 
 <file path=ppt/slides/slide16.xml><?xml version="1.0" encoding="utf-8"?>
-<p:sld xmlns:a="http://schemas.openxmlformats.org/drawingml/2006/main" xmlns:r="http://schemas.openxmlformats.org/officeDocument/2006/relationships" xmlns:p="http://schemas.openxmlformats.org/presentationml/2006/main">
+<p:sld xmlns:a="http://schemas.openxmlformats.org/drawingml/2006/main" xmlns:p="http://schemas.openxmlformats.org/presentationml/2006/main" xmlns:r="http://schemas.openxmlformats.org/officeDocument/2006/relationships">
   <p:cSld>
     <p:spTree>
       <p:nvGrpSpPr>
@@ -7640,14 +7892,7 @@
         <p:cNvGrpSpPr/>
         <p:nvPr/>
       </p:nvGrpSpPr>
-      <p:grpSpPr>
-        <a:xfrm>
-          <a:off x="0" y="0"/>
-          <a:ext cx="0" cy="0"/>
-          <a:chOff x="0" y="0"/>
-          <a:chExt cx="0" cy="0"/>
-        </a:xfrm>
-      </p:grpSpPr>
+      <p:grpSpPr/>
       <p:sp>
         <p:nvSpPr>
           <p:cNvPr id="2" name="Title 1"/>
@@ -7655,7 +7900,7 @@
             <a:spLocks noGrp="1"/>
           </p:cNvSpPr>
           <p:nvPr>
-            <p:ph type="ctrTitle"/>
+            <p:ph type="title"/>
           </p:nvPr>
         </p:nvSpPr>
         <p:spPr/>
@@ -7664,7 +7909,970 @@
           <a:lstStyle/>
           <a:p>
             <a:r>
-              <a:t>Discussion</a:t>
+              <a:t>The design: a whole-beach egress survey across six approaches</a:t>
+            </a:r>
+          </a:p>
+        </p:txBody>
+      </p:sp>
+      <p:graphicFrame>
+        <p:nvGraphicFramePr>
+          <p:cNvPr id="3" name="Table 2"/>
+          <p:cNvGraphicFramePr>
+            <a:graphicFrameLocks noGrp="1"/>
+          </p:cNvGraphicFramePr>
+          <p:nvPr/>
+        </p:nvGraphicFramePr>
+        <p:xfrm>
+          <a:off x="594360" y="1325880"/>
+          <a:ext cx="10607040" cy="2560320"/>
+        </p:xfrm>
+        <a:graphic>
+          <a:graphicData uri="http://schemas.openxmlformats.org/drawingml/2006/table">
+            <a:tbl>
+              <a:tblPr firstRow="1" bandRow="1">
+                <a:tableStyleId>{5C22544A-7EE6-4342-B048-85BDC9FD1C3A}</a:tableStyleId>
+              </a:tblPr>
+              <a:tblGrid>
+                <a:gridCol w="3657600"/>
+                <a:gridCol w="4937760"/>
+                <a:gridCol w="2011680"/>
+              </a:tblGrid>
+              <a:tr h="365760">
+                <a:tc>
+                  <a:txBody>
+                    <a:bodyPr/>
+                    <a:lstStyle/>
+                    <a:p>
+                      <a:r>
+                        <a:rPr sz="1300" b="1">
+                          <a:solidFill>
+                            <a:srgbClr val="FFFFFF"/>
+                          </a:solidFill>
+                        </a:rPr>
+                        <a:t>Vehicle approach  (south to north)</a:t>
+                      </a:r>
+                    </a:p>
+                  </a:txBody>
+                  <a:tcPr>
+                    <a:solidFill>
+                      <a:srgbClr val="1B3A5C"/>
+                    </a:solidFill>
+                  </a:tcPr>
+                </a:tc>
+                <a:tc>
+                  <a:txBody>
+                    <a:bodyPr/>
+                    <a:lstStyle/>
+                    <a:p>
+                      <a:r>
+                        <a:rPr sz="1300" b="1">
+                          <a:solidFill>
+                            <a:srgbClr val="FFFFFF"/>
+                          </a:solidFill>
+                        </a:rPr>
+                        <a:t>Historical egress coverage</a:t>
+                      </a:r>
+                    </a:p>
+                  </a:txBody>
+                  <a:tcPr>
+                    <a:solidFill>
+                      <a:srgbClr val="1B3A5C"/>
+                    </a:solidFill>
+                  </a:tcPr>
+                </a:tc>
+                <a:tc>
+                  <a:txBody>
+                    <a:bodyPr/>
+                    <a:lstStyle/>
+                    <a:p>
+                      <a:r>
+                        <a:rPr sz="1300" b="1">
+                          <a:solidFill>
+                            <a:srgbClr val="FFFFFF"/>
+                          </a:solidFill>
+                        </a:rPr>
+                        <a:t>Pilot role</a:t>
+                      </a:r>
+                    </a:p>
+                  </a:txBody>
+                  <a:tcPr>
+                    <a:solidFill>
+                      <a:srgbClr val="1B3A5C"/>
+                    </a:solidFill>
+                  </a:tcPr>
+                </a:tc>
+              </a:tr>
+              <a:tr h="365760">
+                <a:tc>
+                  <a:txBody>
+                    <a:bodyPr/>
+                    <a:lstStyle/>
+                    <a:p>
+                      <a:r>
+                        <a:rPr sz="1200"/>
+                        <a:t>Seaview</a:t>
+                      </a:r>
+                    </a:p>
+                  </a:txBody>
+                  <a:tcPr/>
+                </a:tc>
+                <a:tc>
+                  <a:txBody>
+                    <a:bodyPr/>
+                    <a:lstStyle/>
+                    <a:p>
+                      <a:r>
+                        <a:rPr sz="1200"/>
+                        <a:t>2004 only (south to Beards Hollow)</a:t>
+                      </a:r>
+                    </a:p>
+                  </a:txBody>
+                  <a:tcPr/>
+                </a:tc>
+                <a:tc>
+                  <a:txBody>
+                    <a:bodyPr/>
+                    <a:lstStyle/>
+                    <a:p>
+                      <a:r>
+                        <a:rPr sz="1200"/>
+                        <a:t>Counter</a:t>
+                      </a:r>
+                    </a:p>
+                  </a:txBody>
+                  <a:tcPr/>
+                </a:tc>
+              </a:tr>
+              <a:tr h="365760">
+                <a:tc>
+                  <a:txBody>
+                    <a:bodyPr/>
+                    <a:lstStyle/>
+                    <a:p>
+                      <a:r>
+                        <a:rPr sz="1200"/>
+                        <a:t>Long Beach (Bolstad)</a:t>
+                      </a:r>
+                    </a:p>
+                  </a:txBody>
+                  <a:tcPr/>
+                </a:tc>
+                <a:tc>
+                  <a:txBody>
+                    <a:bodyPr/>
+                    <a:lstStyle/>
+                    <a:p>
+                      <a:r>
+                        <a:rPr sz="1200"/>
+                        <a:t>never counted</a:t>
+                      </a:r>
+                    </a:p>
+                  </a:txBody>
+                  <a:tcPr/>
+                </a:tc>
+                <a:tc>
+                  <a:txBody>
+                    <a:bodyPr/>
+                    <a:lstStyle/>
+                    <a:p>
+                      <a:r>
+                        <a:rPr sz="1200"/>
+                        <a:t>Counter</a:t>
+                      </a:r>
+                    </a:p>
+                  </a:txBody>
+                  <a:tcPr/>
+                </a:tc>
+              </a:tr>
+              <a:tr h="365760">
+                <a:tc>
+                  <a:txBody>
+                    <a:bodyPr/>
+                    <a:lstStyle/>
+                    <a:p>
+                      <a:r>
+                        <a:rPr sz="1200"/>
+                        <a:t>Cranberry</a:t>
+                      </a:r>
+                    </a:p>
+                  </a:txBody>
+                  <a:tcPr/>
+                </a:tc>
+                <a:tc>
+                  <a:txBody>
+                    <a:bodyPr/>
+                    <a:lstStyle/>
+                    <a:p>
+                      <a:r>
+                        <a:rPr sz="1200"/>
+                        <a:t>never counted</a:t>
+                      </a:r>
+                    </a:p>
+                  </a:txBody>
+                  <a:tcPr/>
+                </a:tc>
+                <a:tc>
+                  <a:txBody>
+                    <a:bodyPr/>
+                    <a:lstStyle/>
+                    <a:p>
+                      <a:r>
+                        <a:rPr sz="1200"/>
+                        <a:t>Counter</a:t>
+                      </a:r>
+                    </a:p>
+                  </a:txBody>
+                  <a:tcPr/>
+                </a:tc>
+              </a:tr>
+              <a:tr h="365760">
+                <a:tc>
+                  <a:txBody>
+                    <a:bodyPr/>
+                    <a:lstStyle/>
+                    <a:p>
+                      <a:r>
+                        <a:rPr sz="1200"/>
+                        <a:t>Klipsan</a:t>
+                      </a:r>
+                    </a:p>
+                  </a:txBody>
+                  <a:tcPr/>
+                </a:tc>
+                <a:tc>
+                  <a:txBody>
+                    <a:bodyPr/>
+                    <a:lstStyle/>
+                    <a:p>
+                      <a:r>
+                        <a:rPr sz="1200"/>
+                        <a:t>never counted</a:t>
+                      </a:r>
+                    </a:p>
+                  </a:txBody>
+                  <a:tcPr/>
+                </a:tc>
+                <a:tc>
+                  <a:txBody>
+                    <a:bodyPr/>
+                    <a:lstStyle/>
+                    <a:p>
+                      <a:r>
+                        <a:rPr sz="1200"/>
+                        <a:t>Counter</a:t>
+                      </a:r>
+                    </a:p>
+                  </a:txBody>
+                  <a:tcPr/>
+                </a:tc>
+              </a:tr>
+              <a:tr h="365760">
+                <a:tc>
+                  <a:txBody>
+                    <a:bodyPr/>
+                    <a:lstStyle/>
+                    <a:p>
+                      <a:r>
+                        <a:rPr sz="1200"/>
+                        <a:t>Ocean Park</a:t>
+                      </a:r>
+                    </a:p>
+                  </a:txBody>
+                  <a:tcPr/>
+                </a:tc>
+                <a:tc>
+                  <a:txBody>
+                    <a:bodyPr/>
+                    <a:lstStyle/>
+                    <a:p>
+                      <a:r>
+                        <a:rPr sz="1200"/>
+                        <a:t>never counted</a:t>
+                      </a:r>
+                    </a:p>
+                  </a:txBody>
+                  <a:tcPr/>
+                </a:tc>
+                <a:tc>
+                  <a:txBody>
+                    <a:bodyPr/>
+                    <a:lstStyle/>
+                    <a:p>
+                      <a:r>
+                        <a:rPr sz="1200"/>
+                        <a:t>Counter</a:t>
+                      </a:r>
+                    </a:p>
+                  </a:txBody>
+                  <a:tcPr/>
+                </a:tc>
+              </a:tr>
+              <a:tr h="365760">
+                <a:tc>
+                  <a:txBody>
+                    <a:bodyPr/>
+                    <a:lstStyle/>
+                    <a:p>
+                      <a:r>
+                        <a:rPr sz="1200"/>
+                        <a:t>Oysterville</a:t>
+                      </a:r>
+                    </a:p>
+                  </a:txBody>
+                  <a:tcPr/>
+                </a:tc>
+                <a:tc>
+                  <a:txBody>
+                    <a:bodyPr/>
+                    <a:lstStyle/>
+                    <a:p>
+                      <a:r>
+                        <a:rPr sz="1200"/>
+                        <a:t>1990, 1998, 2004, 2011 (north to Leadbetter)</a:t>
+                      </a:r>
+                    </a:p>
+                  </a:txBody>
+                  <a:tcPr/>
+                </a:tc>
+                <a:tc>
+                  <a:txBody>
+                    <a:bodyPr/>
+                    <a:lstStyle/>
+                    <a:p>
+                      <a:r>
+                        <a:rPr sz="1200"/>
+                        <a:t>Counter</a:t>
+                      </a:r>
+                    </a:p>
+                  </a:txBody>
+                  <a:tcPr/>
+                </a:tc>
+              </a:tr>
+            </a:tbl>
+          </a:graphicData>
+        </a:graphic>
+      </p:graphicFrame>
+      <p:sp>
+        <p:nvSpPr>
+          <p:cNvPr id="4" name="TextBox 3"/>
+          <p:cNvSpPr txBox="1"/>
+          <p:nvPr/>
+        </p:nvSpPr>
+        <p:spPr>
+          <a:xfrm>
+            <a:off x="594360" y="4297680"/>
+            <a:ext cx="10972800" cy="1554480"/>
+          </a:xfrm>
+          <a:prstGeom prst="rect">
+            <a:avLst/>
+          </a:prstGeom>
+          <a:noFill/>
+        </p:spPr>
+        <p:txBody>
+          <a:bodyPr wrap="square">
+            <a:spAutoFit/>
+          </a:bodyPr>
+          <a:lstStyle/>
+          <a:p>
+            <a:r>
+              <a:rPr sz="1300"/>
+              <a:t>One counter per approach records cars on and off in 15-minute bins across the tidal window (about three hours before to ninety minutes after low water); a roving crew runs the instantaneous beach count near the peak and works the full length for catch and effort. Long Beach splits into seven census sections between Beards Hollow and Leadbetter Point. Four of its six approaches have never been counted, and no survey has ever counted all six on the same day: coverage was one end or the other, on separate days. This is the first whole-beach measurement.</a:t>
+            </a:r>
+          </a:p>
+        </p:txBody>
+      </p:sp>
+    </p:spTree>
+  </p:cSld>
+  <p:clrMapOvr>
+    <a:masterClrMapping/>
+  </p:clrMapOvr>
+</p:sld>
+</file>
+
+<file path=ppt/slides/slide17.xml><?xml version="1.0" encoding="utf-8"?>
+<p:sld xmlns:a="http://schemas.openxmlformats.org/drawingml/2006/main" xmlns:p="http://schemas.openxmlformats.org/presentationml/2006/main" xmlns:r="http://schemas.openxmlformats.org/officeDocument/2006/relationships">
+  <p:cSld>
+    <p:spTree>
+      <p:nvGrpSpPr>
+        <p:cNvPr id="1" name=""/>
+        <p:cNvGrpSpPr/>
+        <p:nvPr/>
+      </p:nvGrpSpPr>
+      <p:grpSpPr/>
+      <p:sp>
+        <p:nvSpPr>
+          <p:cNvPr id="2" name="Title 1"/>
+          <p:cNvSpPr>
+            <a:spLocks noGrp="1"/>
+          </p:cNvSpPr>
+          <p:nvPr>
+            <p:ph type="title"/>
+          </p:nvPr>
+        </p:nvSpPr>
+        <p:spPr/>
+        <p:txBody>
+          <a:bodyPr/>
+          <a:lstStyle/>
+          <a:p>
+            <a:r>
+              <a:t>Staffing: eight for Long Beach, thirteen with a paired northern beach</a:t>
+            </a:r>
+          </a:p>
+        </p:txBody>
+      </p:sp>
+      <p:graphicFrame>
+        <p:nvGraphicFramePr>
+          <p:cNvPr id="3" name="Table 2"/>
+          <p:cNvGraphicFramePr>
+            <a:graphicFrameLocks noGrp="1"/>
+          </p:cNvGraphicFramePr>
+          <p:nvPr/>
+        </p:nvGraphicFramePr>
+        <p:xfrm>
+          <a:off x="594360" y="1325880"/>
+          <a:ext cx="10972800" cy="2194560"/>
+        </p:xfrm>
+        <a:graphic>
+          <a:graphicData uri="http://schemas.openxmlformats.org/drawingml/2006/table">
+            <a:tbl>
+              <a:tblPr firstRow="1" bandRow="1">
+                <a:tableStyleId>{5C22544A-7EE6-4342-B048-85BDC9FD1C3A}</a:tableStyleId>
+              </a:tblPr>
+              <a:tblGrid>
+                <a:gridCol w="5120640"/>
+                <a:gridCol w="1188720"/>
+                <a:gridCol w="4663440"/>
+              </a:tblGrid>
+              <a:tr h="365760">
+                <a:tc>
+                  <a:txBody>
+                    <a:bodyPr/>
+                    <a:lstStyle/>
+                    <a:p>
+                      <a:r>
+                        <a:rPr sz="1300" b="1">
+                          <a:solidFill>
+                            <a:srgbClr val="FFFFFF"/>
+                          </a:solidFill>
+                        </a:rPr>
+                        <a:t>Role</a:t>
+                      </a:r>
+                    </a:p>
+                  </a:txBody>
+                  <a:tcPr>
+                    <a:solidFill>
+                      <a:srgbClr val="1B3A5C"/>
+                    </a:solidFill>
+                  </a:tcPr>
+                </a:tc>
+                <a:tc>
+                  <a:txBody>
+                    <a:bodyPr/>
+                    <a:lstStyle/>
+                    <a:p>
+                      <a:r>
+                        <a:rPr sz="1300" b="1">
+                          <a:solidFill>
+                            <a:srgbClr val="FFFFFF"/>
+                          </a:solidFill>
+                        </a:rPr>
+                        <a:t>Staff</a:t>
+                      </a:r>
+                    </a:p>
+                  </a:txBody>
+                  <a:tcPr>
+                    <a:solidFill>
+                      <a:srgbClr val="1B3A5C"/>
+                    </a:solidFill>
+                  </a:tcPr>
+                </a:tc>
+                <a:tc>
+                  <a:txBody>
+                    <a:bodyPr/>
+                    <a:lstStyle/>
+                    <a:p>
+                      <a:r>
+                        <a:rPr sz="1300" b="1">
+                          <a:solidFill>
+                            <a:srgbClr val="FFFFFF"/>
+                          </a:solidFill>
+                        </a:rPr>
+                        <a:t>Basis</a:t>
+                      </a:r>
+                    </a:p>
+                  </a:txBody>
+                  <a:tcPr>
+                    <a:solidFill>
+                      <a:srgbClr val="1B3A5C"/>
+                    </a:solidFill>
+                  </a:tcPr>
+                </a:tc>
+              </a:tr>
+              <a:tr h="365760">
+                <a:tc>
+                  <a:txBody>
+                    <a:bodyPr/>
+                    <a:lstStyle/>
+                    <a:p>
+                      <a:r>
+                        <a:rPr sz="1200"/>
+                        <a:t>Approach counters</a:t>
+                      </a:r>
+                    </a:p>
+                  </a:txBody>
+                  <a:tcPr/>
+                </a:tc>
+                <a:tc>
+                  <a:txBody>
+                    <a:bodyPr/>
+                    <a:lstStyle/>
+                    <a:p>
+                      <a:r>
+                        <a:rPr sz="1200"/>
+                        <a:t>6</a:t>
+                      </a:r>
+                    </a:p>
+                  </a:txBody>
+                  <a:tcPr/>
+                </a:tc>
+                <a:tc>
+                  <a:txBody>
+                    <a:bodyPr/>
+                    <a:lstStyle/>
+                    <a:p>
+                      <a:r>
+                        <a:rPr sz="1200"/>
+                        <a:t>one per drivable approach (1998 field model)</a:t>
+                      </a:r>
+                    </a:p>
+                  </a:txBody>
+                  <a:tcPr/>
+                </a:tc>
+              </a:tr>
+              <a:tr h="365760">
+                <a:tc>
+                  <a:txBody>
+                    <a:bodyPr/>
+                    <a:lstStyle/>
+                    <a:p>
+                      <a:r>
+                        <a:rPr sz="1200"/>
+                        <a:t>Roving beach-count / interview crews</a:t>
+                      </a:r>
+                    </a:p>
+                  </a:txBody>
+                  <a:tcPr/>
+                </a:tc>
+                <a:tc>
+                  <a:txBody>
+                    <a:bodyPr/>
+                    <a:lstStyle/>
+                    <a:p>
+                      <a:r>
+                        <a:rPr sz="1200"/>
+                        <a:t>2</a:t>
+                      </a:r>
+                    </a:p>
+                  </a:txBody>
+                  <a:tcPr/>
+                </a:tc>
+                <a:tc>
+                  <a:txBody>
+                    <a:bodyPr/>
+                    <a:lstStyle/>
+                    <a:p>
+                      <a:r>
+                        <a:rPr sz="1200"/>
+                        <a:t>28-mile beach, up to ~5,200 trips on a 90th-percentile day</a:t>
+                      </a:r>
+                    </a:p>
+                  </a:txBody>
+                  <a:tcPr/>
+                </a:tc>
+              </a:tr>
+              <a:tr h="365760">
+                <a:tc>
+                  <a:txBody>
+                    <a:bodyPr/>
+                    <a:lstStyle/>
+                    <a:p>
+                      <a:r>
+                        <a:rPr sz="1200" b="1"/>
+                        <a:t>Long Beach core, per survey day</a:t>
+                      </a:r>
+                    </a:p>
+                  </a:txBody>
+                  <a:tcPr/>
+                </a:tc>
+                <a:tc>
+                  <a:txBody>
+                    <a:bodyPr/>
+                    <a:lstStyle/>
+                    <a:p>
+                      <a:r>
+                        <a:rPr sz="1200" b="1"/>
+                        <a:t>8</a:t>
+                      </a:r>
+                    </a:p>
+                  </a:txBody>
+                  <a:tcPr/>
+                </a:tc>
+                <a:tc>
+                  <a:txBody>
+                    <a:bodyPr/>
+                    <a:lstStyle/>
+                    <a:p/>
+                  </a:txBody>
+                  <a:tcPr/>
+                </a:tc>
+              </a:tr>
+              <a:tr h="365760">
+                <a:tc>
+                  <a:txBody>
+                    <a:bodyPr/>
+                    <a:lstStyle/>
+                    <a:p>
+                      <a:r>
+                        <a:rPr sz="1200"/>
+                        <a:t>Paired northern egress (Copalis or Mocrocks)</a:t>
+                      </a:r>
+                    </a:p>
+                  </a:txBody>
+                  <a:tcPr/>
+                </a:tc>
+                <a:tc>
+                  <a:txBody>
+                    <a:bodyPr/>
+                    <a:lstStyle/>
+                    <a:p>
+                      <a:r>
+                        <a:rPr sz="1200"/>
+                        <a:t>+5</a:t>
+                      </a:r>
+                    </a:p>
+                  </a:txBody>
+                  <a:tcPr/>
+                </a:tc>
+                <a:tc>
+                  <a:txBody>
+                    <a:bodyPr/>
+                    <a:lstStyle/>
+                    <a:p>
+                      <a:r>
+                        <a:rPr sz="1200"/>
+                        <a:t>same-day donor truth on a subset of days</a:t>
+                      </a:r>
+                    </a:p>
+                  </a:txBody>
+                  <a:tcPr/>
+                </a:tc>
+              </a:tr>
+              <a:tr h="365760">
+                <a:tc>
+                  <a:txBody>
+                    <a:bodyPr/>
+                    <a:lstStyle/>
+                    <a:p>
+                      <a:r>
+                        <a:rPr sz="1200" b="1"/>
+                        <a:t>Peak, on a paired day</a:t>
+                      </a:r>
+                    </a:p>
+                  </a:txBody>
+                  <a:tcPr/>
+                </a:tc>
+                <a:tc>
+                  <a:txBody>
+                    <a:bodyPr/>
+                    <a:lstStyle/>
+                    <a:p>
+                      <a:r>
+                        <a:rPr sz="1200" b="1"/>
+                        <a:t>13</a:t>
+                      </a:r>
+                    </a:p>
+                  </a:txBody>
+                  <a:tcPr/>
+                </a:tc>
+                <a:tc>
+                  <a:txBody>
+                    <a:bodyPr/>
+                    <a:lstStyle/>
+                    <a:p/>
+                  </a:txBody>
+                  <a:tcPr/>
+                </a:tc>
+              </a:tr>
+            </a:tbl>
+          </a:graphicData>
+        </a:graphic>
+      </p:graphicFrame>
+      <p:sp>
+        <p:nvSpPr>
+          <p:cNvPr id="4" name="TextBox 3"/>
+          <p:cNvSpPr txBox="1"/>
+          <p:nvPr/>
+        </p:nvSpPr>
+        <p:spPr>
+          <a:xfrm>
+            <a:off x="594360" y="4160520"/>
+            <a:ext cx="10972800" cy="1554480"/>
+          </a:xfrm>
+          <a:prstGeom prst="rect">
+            <a:avLst/>
+          </a:prstGeom>
+          <a:noFill/>
+        </p:spPr>
+        <p:txBody>
+          <a:bodyPr wrap="square">
+            <a:spAutoFit/>
+          </a:bodyPr>
+          <a:lstStyle/>
+          <a:p>
+            <a:r>
+              <a:rPr sz="1300"/>
+              <a:t>Counters are stationary and low-skill (enforcement, seasonals, trained volunteers); the roving crews are the program's regular samplers, who are on the beach that day regardless, so the marginal cost is mainly the six counters. On a subset of days, add a whole-beach egress at whichever northern donor the state is digging that day. That yields paired same-day truth at donor and target, measuring the imputation transfer directly and adding to the 97 same-day pairs that anchor the joint-donor error (sd 0.43).</a:t>
+            </a:r>
+          </a:p>
+        </p:txBody>
+      </p:sp>
+    </p:spTree>
+  </p:cSld>
+  <p:clrMapOvr>
+    <a:masterClrMapping/>
+  </p:clrMapOvr>
+</p:sld>
+</file>
+
+<file path=ppt/slides/slide18.xml><?xml version="1.0" encoding="utf-8"?>
+<p:sld xmlns:a="http://schemas.openxmlformats.org/drawingml/2006/main" xmlns:p="http://schemas.openxmlformats.org/presentationml/2006/main" xmlns:r="http://schemas.openxmlformats.org/officeDocument/2006/relationships">
+  <p:cSld>
+    <p:spTree>
+      <p:nvGrpSpPr>
+        <p:cNvPr id="1" name=""/>
+        <p:cNvGrpSpPr/>
+        <p:nvPr/>
+      </p:nvGrpSpPr>
+      <p:grpSpPr/>
+      <p:sp>
+        <p:nvSpPr>
+          <p:cNvPr id="2" name="Title 1"/>
+          <p:cNvSpPr>
+            <a:spLocks noGrp="1"/>
+          </p:cNvSpPr>
+          <p:nvPr>
+            <p:ph type="title"/>
+          </p:nvPr>
+        </p:nvSpPr>
+        <p:spPr/>
+        <p:txBody>
+          <a:bodyPr/>
+          <a:lstStyle/>
+          <a:p>
+            <a:r>
+              <a:t>What it buys: from 18% toward 6%, and a template for partial surveys</a:t>
+            </a:r>
+          </a:p>
+        </p:txBody>
+      </p:sp>
+      <p:sp>
+        <p:nvSpPr>
+          <p:cNvPr id="3" name="Content Placeholder 2"/>
+          <p:cNvSpPr>
+            <a:spLocks noGrp="1"/>
+          </p:cNvSpPr>
+          <p:nvPr>
+            <p:ph idx="1" sz="half"/>
+          </p:nvPr>
+        </p:nvSpPr>
+        <p:spPr/>
+        <p:txBody>
+          <a:bodyPr wrap="square"/>
+          <a:lstStyle/>
+          <a:p>
+            <a:r>
+              <a:rPr b="1" sz="1400"/>
+              <a:t>Today: 18.4% relative sd on three daylight surveys, newest 2011. </a:t>
+            </a:r>
+            <a:r>
+              <a:rPr sz="1400"/>
+              <a:t>Between-survey error falls as one over the root of the survey count.</a:t>
+            </a:r>
+          </a:p>
+          <a:p>
+            <a:r>
+              <a:rPr b="1" sz="1400"/>
+              <a:t>A pilot season (~8 whole-beach surveys) </a:t>
+            </a:r>
+            <a:r>
+              <a:rPr sz="1400"/>
+              <a:t>roughly halves it to ~11%; a ~16-survey rebuild reaches ~8%, approaching the ~6% of the refreshed northern beaches.</a:t>
+            </a:r>
+          </a:p>
+          <a:p>
+            <a:r>
+              <a:rPr b="1" sz="1400"/>
+              <a:t>Whole-beach coverage also retires the section-ratio error (sd 0.281) </a:t>
+            </a:r>
+            <a:r>
+              <a:rPr sz="1400"/>
+              <a:t>that the historical single-approach partials cannot.</a:t>
+            </a:r>
+          </a:p>
+          <a:p>
+            <a:r>
+              <a:rPr b="1" sz="1400"/>
+              <a:t>It calibrates the section shares, </a:t>
+            </a:r>
+            <a:r>
+              <a:rPr sz="1400"/>
+              <a:t>so future cheap partial surveys (one approach) can be expanded reliably instead of imputed.</a:t>
+            </a:r>
+          </a:p>
+        </p:txBody>
+      </p:sp>
+      <p:sp>
+        <p:nvSpPr>
+          <p:cNvPr id="5" name="Content Placeholder 4"/>
+          <p:cNvSpPr>
+            <a:spLocks noGrp="1"/>
+          </p:cNvSpPr>
+          <p:nvPr>
+            <p:ph idx="11" sz="half"/>
+          </p:nvPr>
+        </p:nvSpPr>
+        <p:spPr/>
+        <p:txBody>
+          <a:bodyPr/>
+          <a:lstStyle/>
+          <a:p/>
+        </p:txBody>
+      </p:sp>
+      <p:pic>
+        <p:nvPicPr>
+          <p:cNvPr id="6" name="Picture 5" descr="fig16_lb_survey_target.png"/>
+          <p:cNvPicPr>
+            <a:picLocks noChangeAspect="1"/>
+          </p:cNvPicPr>
+          <p:nvPr/>
+        </p:nvPicPr>
+        <p:blipFill>
+          <a:blip r:embed="rId2"/>
+          <a:stretch>
+            <a:fillRect/>
+          </a:stretch>
+        </p:blipFill>
+        <p:spPr>
+          <a:xfrm>
+            <a:off x="6178610" y="1692602"/>
+            <a:ext cx="5403790" cy="3242274"/>
+          </a:xfrm>
+          <a:prstGeom prst="rect">
+            <a:avLst/>
+          </a:prstGeom>
+        </p:spPr>
+      </p:pic>
+    </p:spTree>
+  </p:cSld>
+  <p:clrMapOvr>
+    <a:masterClrMapping/>
+  </p:clrMapOvr>
+</p:sld>
+</file>
+
+<file path=ppt/slides/slide19.xml><?xml version="1.0" encoding="utf-8"?>
+<p:sld xmlns:a="http://schemas.openxmlformats.org/drawingml/2006/main" xmlns:p="http://schemas.openxmlformats.org/presentationml/2006/main" xmlns:r="http://schemas.openxmlformats.org/officeDocument/2006/relationships">
+  <p:cSld>
+    <p:spTree>
+      <p:nvGrpSpPr>
+        <p:cNvPr id="1" name=""/>
+        <p:cNvGrpSpPr/>
+        <p:nvPr/>
+      </p:nvGrpSpPr>
+      <p:grpSpPr/>
+      <p:sp>
+        <p:nvSpPr>
+          <p:cNvPr id="2" name="Title 1"/>
+          <p:cNvSpPr>
+            <a:spLocks noGrp="1"/>
+          </p:cNvSpPr>
+          <p:nvPr>
+            <p:ph type="title"/>
+          </p:nvPr>
+        </p:nvSpPr>
+        <p:spPr/>
+        <p:txBody>
+          <a:bodyPr/>
+          <a:lstStyle/>
+          <a:p>
+            <a:r>
+              <a:t>Recommendations, in priority order</a:t>
+            </a:r>
+          </a:p>
+        </p:txBody>
+      </p:sp>
+      <p:sp>
+        <p:nvSpPr>
+          <p:cNvPr id="3" name="Content Placeholder 2"/>
+          <p:cNvSpPr>
+            <a:spLocks noGrp="1"/>
+          </p:cNvSpPr>
+          <p:nvPr>
+            <p:ph idx="1"/>
+          </p:nvPr>
+        </p:nvSpPr>
+        <p:spPr/>
+        <p:txBody>
+          <a:bodyPr wrap="square"/>
+          <a:lstStyle/>
+          <a:p>
+            <a:r>
+              <a:rPr b="1" sz="1400"/>
+              <a:t>1.  Survey Long Beach first. </a:t>
+            </a:r>
+            <a:r>
+              <a:rPr sz="1400"/>
+              <a:t>Run the whole-beach egress pilot, six approaches and about eight staff, both tide conditions. The correction factor is the largest term and Long Beach's table is the thinnest and oldest.</a:t>
+            </a:r>
+          </a:p>
+          <a:p>
+            <a:r>
+              <a:rPr b="1" sz="1400"/>
+              <a:t>2.  Hold the southern donor at its co-management floor. </a:t>
+            </a:r>
+            <a:r>
+              <a:rPr sz="1400"/>
+              <a:t>Keep one of Copalis or Mocrocks state-counted every dig day, which the 2-on / 2-off calendar already delivers. The Quinault's alternate-day counts cannot substitute for the state.</a:t>
+            </a:r>
+          </a:p>
+          <a:p>
+            <a:r>
+              <a:rPr b="1" sz="1400"/>
+              <a:t>3.  Pair the pilot with the northern donor on a subset of days </a:t>
+            </a:r>
+            <a:r>
+              <a:rPr sz="1400"/>
+              <a:t>to measure the imputation transfer directly and tighten the joint-donor error, rather than leaning on the modeled lag curve.</a:t>
+            </a:r>
+          </a:p>
+          <a:p>
+            <a:r>
+              <a:rPr b="1" sz="1400"/>
+              <a:t>4.  Treat the 45% reallocation as optional, not free. </a:t>
+            </a:r>
+            <a:r>
+              <a:rPr sz="1400"/>
+              <a:t>It buys direct Long Beach precision but degrades the donor with no offset; fund Long Beach from dedicated effort where possible.</a:t>
+            </a:r>
+          </a:p>
+          <a:p>
+            <a:r>
+              <a:rPr b="1" sz="1400"/>
+              <a:t>5.  Accept the Copalis floor: </a:t>
+            </a:r>
+            <a:r>
+              <a:rPr sz="1400"/>
+              <a:t>a harvest CV of 0.10 is infeasible there at any sampling rate, only more surveys would move it.</a:t>
             </a:r>
           </a:p>
         </p:txBody>
@@ -7678,7 +8886,7 @@
 </file>
 
 <file path=ppt/slides/slide2.xml><?xml version="1.0" encoding="utf-8"?>
-<p:sld xmlns:a="http://schemas.openxmlformats.org/drawingml/2006/main" xmlns:r="http://schemas.openxmlformats.org/officeDocument/2006/relationships" xmlns:p="http://schemas.openxmlformats.org/presentationml/2006/main">
+<p:sld xmlns:a="http://schemas.openxmlformats.org/drawingml/2006/main" xmlns:p="http://schemas.openxmlformats.org/presentationml/2006/main" xmlns:r="http://schemas.openxmlformats.org/officeDocument/2006/relationships">
   <p:cSld>
     <p:spTree>
       <p:nvGrpSpPr>
@@ -7686,14 +8894,7 @@
         <p:cNvGrpSpPr/>
         <p:nvPr/>
       </p:nvGrpSpPr>
-      <p:grpSpPr>
-        <a:xfrm>
-          <a:off x="0" y="0"/>
-          <a:ext cx="0" cy="0"/>
-          <a:chOff x="0" y="0"/>
-          <a:chExt cx="0" cy="0"/>
-        </a:xfrm>
-      </p:grpSpPr>
+      <p:grpSpPr/>
       <p:sp>
         <p:nvSpPr>
           <p:cNvPr id="2" name="Title 1"/>
@@ -7727,40 +8928,73 @@
         </p:nvSpPr>
         <p:spPr/>
         <p:txBody>
-          <a:bodyPr wrap="square">
-            <a:normAutofit/>
-          </a:bodyPr>
+          <a:bodyPr wrap="square"/>
           <a:lstStyle/>
           <a:p>
             <a:r>
-              <a:rPr sz="2800" b="1" dirty="0"/>
+              <a:rPr b="1"/>
               <a:t>Given a crew of finite size: </a:t>
             </a:r>
             <a:r>
-              <a:rPr sz="2800" dirty="0"/>
               <a:t>how many beach-days per tide series must be counted, and which ones?</a:t>
             </a:r>
           </a:p>
           <a:p>
             <a:r>
-              <a:rPr sz="2800" dirty="0"/>
               <a:t>This is new work, the program has never had a quantitative answer.</a:t>
             </a:r>
           </a:p>
           <a:p>
             <a:r>
-              <a:rPr sz="2800" b="1" dirty="0"/>
+              <a:rPr b="1"/>
               <a:t>Judged against a published standard: </a:t>
             </a:r>
             <a:r>
-              <a:rPr sz="2800" dirty="0"/>
               <a:t>CV ≤ 0.20 (creel-survey design target) and NOAA MRIP's ≤ 0.30 publication threshold.</a:t>
             </a:r>
           </a:p>
           <a:p>
             <a:r>
-              <a:rPr sz="2800" dirty="0"/>
               <a:t>Every figure here is a lower bound: it excludes beach-count observer error, which has never been measured.</a:t>
+            </a:r>
+          </a:p>
+        </p:txBody>
+      </p:sp>
+    </p:spTree>
+  </p:cSld>
+  <p:clrMapOvr>
+    <a:masterClrMapping/>
+  </p:clrMapOvr>
+</p:sld>
+</file>
+
+<file path=ppt/slides/slide20.xml><?xml version="1.0" encoding="utf-8"?>
+<p:sld xmlns:a="http://schemas.openxmlformats.org/drawingml/2006/main" xmlns:p="http://schemas.openxmlformats.org/presentationml/2006/main" xmlns:r="http://schemas.openxmlformats.org/officeDocument/2006/relationships">
+  <p:cSld>
+    <p:spTree>
+      <p:nvGrpSpPr>
+        <p:cNvPr id="1" name=""/>
+        <p:cNvGrpSpPr/>
+        <p:nvPr/>
+      </p:nvGrpSpPr>
+      <p:grpSpPr/>
+      <p:sp>
+        <p:nvSpPr>
+          <p:cNvPr id="2" name="Title 1"/>
+          <p:cNvSpPr>
+            <a:spLocks noGrp="1"/>
+          </p:cNvSpPr>
+          <p:nvPr>
+            <p:ph type="ctrTitle"/>
+          </p:nvPr>
+        </p:nvSpPr>
+        <p:spPr/>
+        <p:txBody>
+          <a:bodyPr/>
+          <a:lstStyle/>
+          <a:p>
+            <a:r>
+              <a:t>Discussion</a:t>
             </a:r>
           </a:p>
         </p:txBody>
@@ -7774,7 +9008,7 @@
 </file>
 
 <file path=ppt/slides/slide3.xml><?xml version="1.0" encoding="utf-8"?>
-<p:sld xmlns:a="http://schemas.openxmlformats.org/drawingml/2006/main" xmlns:r="http://schemas.openxmlformats.org/officeDocument/2006/relationships" xmlns:p="http://schemas.openxmlformats.org/presentationml/2006/main">
+<p:sld xmlns:a="http://schemas.openxmlformats.org/drawingml/2006/main" xmlns:p="http://schemas.openxmlformats.org/presentationml/2006/main" xmlns:r="http://schemas.openxmlformats.org/officeDocument/2006/relationships">
   <p:cSld>
     <p:spTree>
       <p:nvGrpSpPr>
@@ -7782,14 +9016,7 @@
         <p:cNvGrpSpPr/>
         <p:nvPr/>
       </p:nvGrpSpPr>
-      <p:grpSpPr>
-        <a:xfrm>
-          <a:off x="0" y="0"/>
-          <a:ext cx="0" cy="0"/>
-          <a:chOff x="0" y="0"/>
-          <a:chExt cx="0" cy="0"/>
-        </a:xfrm>
-      </p:grpSpPr>
+      <p:grpSpPr/>
       <p:sp>
         <p:nvSpPr>
           <p:cNvPr id="2" name="Title 1"/>
@@ -7820,7 +9047,7 @@
 </file>
 
 <file path=ppt/slides/slide4.xml><?xml version="1.0" encoding="utf-8"?>
-<p:sld xmlns:a="http://schemas.openxmlformats.org/drawingml/2006/main" xmlns:r="http://schemas.openxmlformats.org/officeDocument/2006/relationships" xmlns:p="http://schemas.openxmlformats.org/presentationml/2006/main">
+<p:sld xmlns:a="http://schemas.openxmlformats.org/drawingml/2006/main" xmlns:p="http://schemas.openxmlformats.org/presentationml/2006/main" xmlns:r="http://schemas.openxmlformats.org/officeDocument/2006/relationships">
   <p:cSld>
     <p:spTree>
       <p:nvGrpSpPr>
@@ -7828,14 +9055,7 @@
         <p:cNvGrpSpPr/>
         <p:nvPr/>
       </p:nvGrpSpPr>
-      <p:grpSpPr>
-        <a:xfrm>
-          <a:off x="0" y="0"/>
-          <a:ext cx="0" cy="0"/>
-          <a:chOff x="0" y="0"/>
-          <a:chExt cx="0" cy="0"/>
-        </a:xfrm>
-      </p:grpSpPr>
+      <p:grpSpPr/>
       <p:sp>
         <p:nvSpPr>
           <p:cNvPr id="2" name="Title 1"/>
@@ -7864,7 +9084,7 @@
             <a:spLocks noGrp="1"/>
           </p:cNvSpPr>
           <p:nvPr>
-            <p:ph sz="half" idx="1"/>
+            <p:ph idx="1" sz="half"/>
           </p:nvPr>
         </p:nvSpPr>
         <p:spPr/>
@@ -7873,7 +9093,7 @@
           <a:lstStyle/>
           <a:p>
             <a:r>
-              <a:rPr sz="1500" b="1"/>
+              <a:rPr b="1" sz="1500"/>
               <a:t>May 2013 correction: </a:t>
             </a:r>
             <a:r>
@@ -7889,7 +9109,7 @@
           </a:p>
           <a:p>
             <a:r>
-              <a:rPr sz="1500" b="1"/>
+              <a:rPr b="1" sz="1500"/>
               <a:t>Long Beach's table was reshaped after 2013: </a:t>
             </a:r>
             <a:r>
@@ -7912,16 +9132,14 @@
             <a:spLocks noGrp="1"/>
           </p:cNvSpPr>
           <p:nvPr>
-            <p:ph sz="half" idx="11"/>
+            <p:ph idx="11" sz="half"/>
           </p:nvPr>
         </p:nvSpPr>
         <p:spPr/>
         <p:txBody>
           <a:bodyPr/>
           <a:lstStyle/>
-          <a:p>
-            <a:endParaRPr/>
-          </a:p>
+          <a:p/>
         </p:txBody>
       </p:sp>
       <p:pic>
@@ -7933,7 +9151,7 @@
           <p:nvPr/>
         </p:nvPicPr>
         <p:blipFill>
-          <a:blip r:embed="rId3"/>
+          <a:blip r:embed="rId2"/>
           <a:stretch>
             <a:fillRect/>
           </a:stretch>
@@ -7957,7 +9175,7 @@
 </file>
 
 <file path=ppt/slides/slide5.xml><?xml version="1.0" encoding="utf-8"?>
-<p:sld xmlns:a="http://schemas.openxmlformats.org/drawingml/2006/main" xmlns:r="http://schemas.openxmlformats.org/officeDocument/2006/relationships" xmlns:p="http://schemas.openxmlformats.org/presentationml/2006/main">
+<p:sld xmlns:a="http://schemas.openxmlformats.org/drawingml/2006/main" xmlns:p="http://schemas.openxmlformats.org/presentationml/2006/main" xmlns:r="http://schemas.openxmlformats.org/officeDocument/2006/relationships">
   <p:cSld>
     <p:spTree>
       <p:nvGrpSpPr>
@@ -7965,14 +9183,7 @@
         <p:cNvGrpSpPr/>
         <p:nvPr/>
       </p:nvGrpSpPr>
-      <p:grpSpPr>
-        <a:xfrm>
-          <a:off x="0" y="0"/>
-          <a:ext cx="0" cy="0"/>
-          <a:chOff x="0" y="0"/>
-          <a:chExt cx="0" cy="0"/>
-        </a:xfrm>
-      </p:grpSpPr>
+      <p:grpSpPr/>
       <p:sp>
         <p:nvSpPr>
           <p:cNvPr id="2" name="Title 1"/>
@@ -8001,7 +9212,7 @@
             <a:spLocks noGrp="1"/>
           </p:cNvSpPr>
           <p:nvPr>
-            <p:ph sz="half" idx="1"/>
+            <p:ph idx="1" sz="half"/>
           </p:nvPr>
         </p:nvSpPr>
         <p:spPr/>
@@ -8010,7 +9221,7 @@
           <a:lstStyle/>
           <a:p>
             <a:r>
-              <a:rPr sz="1500" b="1"/>
+              <a:rPr b="1" sz="1500"/>
               <a:t>71-96% of season effort variance </a:t>
             </a:r>
             <a:r>
@@ -8032,7 +9243,7 @@
           </a:p>
           <a:p>
             <a:r>
-              <a:rPr sz="1500" b="1"/>
+              <a:rPr b="1" sz="1500"/>
               <a:t>The lever is surveys, not crew days </a:t>
             </a:r>
             <a:r>
@@ -8049,16 +9260,14 @@
             <a:spLocks noGrp="1"/>
           </p:cNvSpPr>
           <p:nvPr>
-            <p:ph sz="half" idx="11"/>
+            <p:ph idx="11" sz="half"/>
           </p:nvPr>
         </p:nvSpPr>
         <p:spPr/>
         <p:txBody>
           <a:bodyPr/>
           <a:lstStyle/>
-          <a:p>
-            <a:endParaRPr/>
-          </a:p>
+          <a:p/>
         </p:txBody>
       </p:sp>
       <p:pic>
@@ -8070,7 +9279,7 @@
           <p:nvPr/>
         </p:nvPicPr>
         <p:blipFill>
-          <a:blip r:embed="rId3"/>
+          <a:blip r:embed="rId2"/>
           <a:stretch>
             <a:fillRect/>
           </a:stretch>
@@ -8094,7 +9303,7 @@
 </file>
 
 <file path=ppt/slides/slide6.xml><?xml version="1.0" encoding="utf-8"?>
-<p:sld xmlns:a="http://schemas.openxmlformats.org/drawingml/2006/main" xmlns:r="http://schemas.openxmlformats.org/officeDocument/2006/relationships" xmlns:p="http://schemas.openxmlformats.org/presentationml/2006/main">
+<p:sld xmlns:a="http://schemas.openxmlformats.org/drawingml/2006/main" xmlns:p="http://schemas.openxmlformats.org/presentationml/2006/main" xmlns:r="http://schemas.openxmlformats.org/officeDocument/2006/relationships">
   <p:cSld>
     <p:spTree>
       <p:nvGrpSpPr>
@@ -8102,14 +9311,7 @@
         <p:cNvGrpSpPr/>
         <p:nvPr/>
       </p:nvGrpSpPr>
-      <p:grpSpPr>
-        <a:xfrm>
-          <a:off x="0" y="0"/>
-          <a:ext cx="0" cy="0"/>
-          <a:chOff x="0" y="0"/>
-          <a:chExt cx="0" cy="0"/>
-        </a:xfrm>
-      </p:grpSpPr>
+      <p:grpSpPr/>
       <p:sp>
         <p:nvSpPr>
           <p:cNvPr id="2" name="Title 1"/>
@@ -8138,7 +9340,7 @@
             <a:spLocks noGrp="1"/>
           </p:cNvSpPr>
           <p:nvPr>
-            <p:ph sz="half" idx="1"/>
+            <p:ph idx="1" sz="half"/>
           </p:nvPr>
         </p:nvSpPr>
         <p:spPr/>
@@ -8147,7 +9349,7 @@
           <a:lstStyle/>
           <a:p>
             <a:r>
-              <a:rPr sz="1500" b="1"/>
+              <a:rPr b="1" sz="1500"/>
               <a:t>CPUE transfer (borrowed catch rate on uncounted days): </a:t>
             </a:r>
             <a:r>
@@ -8163,7 +9365,7 @@
           </a:p>
           <a:p>
             <a:r>
-              <a:rPr sz="1500" b="1"/>
+              <a:rPr b="1" sz="1500"/>
               <a:t>Best donor for the two northern beaches: </a:t>
             </a:r>
             <a:r>
@@ -8180,16 +9382,14 @@
             <a:spLocks noGrp="1"/>
           </p:cNvSpPr>
           <p:nvPr>
-            <p:ph sz="half" idx="11"/>
+            <p:ph idx="11" sz="half"/>
           </p:nvPr>
         </p:nvSpPr>
         <p:spPr/>
         <p:txBody>
           <a:bodyPr/>
           <a:lstStyle/>
-          <a:p>
-            <a:endParaRPr/>
-          </a:p>
+          <a:p/>
         </p:txBody>
       </p:sp>
       <p:pic>
@@ -8201,7 +9401,7 @@
           <p:nvPr/>
         </p:nvPicPr>
         <p:blipFill>
-          <a:blip r:embed="rId3"/>
+          <a:blip r:embed="rId2"/>
           <a:stretch>
             <a:fillRect/>
           </a:stretch>
@@ -8225,7 +9425,7 @@
 </file>
 
 <file path=ppt/slides/slide7.xml><?xml version="1.0" encoding="utf-8"?>
-<p:sld xmlns:a="http://schemas.openxmlformats.org/drawingml/2006/main" xmlns:r="http://schemas.openxmlformats.org/officeDocument/2006/relationships" xmlns:p="http://schemas.openxmlformats.org/presentationml/2006/main">
+<p:sld xmlns:a="http://schemas.openxmlformats.org/drawingml/2006/main" xmlns:p="http://schemas.openxmlformats.org/presentationml/2006/main" xmlns:r="http://schemas.openxmlformats.org/officeDocument/2006/relationships">
   <p:cSld>
     <p:spTree>
       <p:nvGrpSpPr>
@@ -8233,14 +9433,7 @@
         <p:cNvGrpSpPr/>
         <p:nvPr/>
       </p:nvGrpSpPr>
-      <p:grpSpPr>
-        <a:xfrm>
-          <a:off x="0" y="0"/>
-          <a:ext cx="0" cy="0"/>
-          <a:chOff x="0" y="0"/>
-          <a:chExt cx="0" cy="0"/>
-        </a:xfrm>
-      </p:grpSpPr>
+      <p:grpSpPr/>
       <p:sp>
         <p:nvSpPr>
           <p:cNvPr id="2" name="Title 1"/>
@@ -8271,7 +9464,7 @@
 </file>
 
 <file path=ppt/slides/slide8.xml><?xml version="1.0" encoding="utf-8"?>
-<p:sld xmlns:a="http://schemas.openxmlformats.org/drawingml/2006/main" xmlns:r="http://schemas.openxmlformats.org/officeDocument/2006/relationships" xmlns:p="http://schemas.openxmlformats.org/presentationml/2006/main">
+<p:sld xmlns:a="http://schemas.openxmlformats.org/drawingml/2006/main" xmlns:p="http://schemas.openxmlformats.org/presentationml/2006/main" xmlns:r="http://schemas.openxmlformats.org/officeDocument/2006/relationships">
   <p:cSld>
     <p:spTree>
       <p:nvGrpSpPr>
@@ -8279,14 +9472,7 @@
         <p:cNvGrpSpPr/>
         <p:nvPr/>
       </p:nvGrpSpPr>
-      <p:grpSpPr>
-        <a:xfrm>
-          <a:off x="0" y="0"/>
-          <a:ext cx="0" cy="0"/>
-          <a:chOff x="0" y="0"/>
-          <a:chExt cx="0" cy="0"/>
-        </a:xfrm>
-      </p:grpSpPr>
+      <p:grpSpPr/>
       <p:sp>
         <p:nvSpPr>
           <p:cNvPr id="2" name="Title 1"/>
@@ -8315,7 +9501,7 @@
             <a:spLocks noGrp="1"/>
           </p:cNvSpPr>
           <p:nvPr>
-            <p:ph sz="half" idx="1"/>
+            <p:ph idx="1" sz="half"/>
           </p:nvPr>
         </p:nvSpPr>
         <p:spPr/>
@@ -8324,7 +9510,7 @@
           <a:lstStyle/>
           <a:p>
             <a:r>
-              <a:rPr sz="1500" b="1"/>
+              <a:rPr b="1" sz="1500"/>
               <a:t>Count 2 of a 4- or 5-day series; </a:t>
             </a:r>
             <a:r>
@@ -8340,7 +9526,7 @@
           </a:p>
           <a:p>
             <a:r>
-              <a:rPr sz="1500" b="1"/>
+              <a:rPr b="1" sz="1500"/>
               <a:t>Read it as 45% of open days, floor of two.</a:t>
             </a:r>
           </a:p>
@@ -8359,16 +9545,14 @@
             <a:spLocks noGrp="1"/>
           </p:cNvSpPr>
           <p:nvPr>
-            <p:ph sz="half" idx="11"/>
+            <p:ph idx="11" sz="half"/>
           </p:nvPr>
         </p:nvSpPr>
         <p:spPr/>
         <p:txBody>
           <a:bodyPr/>
           <a:lstStyle/>
-          <a:p>
-            <a:endParaRPr/>
-          </a:p>
+          <a:p/>
         </p:txBody>
       </p:sp>
       <p:pic>
@@ -8380,7 +9564,7 @@
           <p:nvPr/>
         </p:nvPicPr>
         <p:blipFill>
-          <a:blip r:embed="rId3"/>
+          <a:blip r:embed="rId2"/>
           <a:stretch>
             <a:fillRect/>
           </a:stretch>
@@ -8404,7 +9588,7 @@
 </file>
 
 <file path=ppt/slides/slide9.xml><?xml version="1.0" encoding="utf-8"?>
-<p:sld xmlns:a="http://schemas.openxmlformats.org/drawingml/2006/main" xmlns:r="http://schemas.openxmlformats.org/officeDocument/2006/relationships" xmlns:p="http://schemas.openxmlformats.org/presentationml/2006/main">
+<p:sld xmlns:a="http://schemas.openxmlformats.org/drawingml/2006/main" xmlns:p="http://schemas.openxmlformats.org/presentationml/2006/main" xmlns:r="http://schemas.openxmlformats.org/officeDocument/2006/relationships">
   <p:cSld>
     <p:spTree>
       <p:nvGrpSpPr>
@@ -8412,14 +9596,7 @@
         <p:cNvGrpSpPr/>
         <p:nvPr/>
       </p:nvGrpSpPr>
-      <p:grpSpPr>
-        <a:xfrm>
-          <a:off x="0" y="0"/>
-          <a:ext cx="0" cy="0"/>
-          <a:chOff x="0" y="0"/>
-          <a:chExt cx="0" cy="0"/>
-        </a:xfrm>
-      </p:grpSpPr>
+      <p:grpSpPr/>
       <p:sp>
         <p:nvSpPr>
           <p:cNvPr id="2" name="Title 1"/>
@@ -8453,43 +9630,37 @@
         </p:nvSpPr>
         <p:spPr/>
         <p:txBody>
-          <a:bodyPr wrap="square">
-            <a:normAutofit/>
-          </a:bodyPr>
+          <a:bodyPr wrap="square"/>
           <a:lstStyle/>
           <a:p>
             <a:r>
-              <a:rPr sz="2800" b="1" dirty="0"/>
+              <a:rPr b="1"/>
               <a:t>Selecting the largest-effort days beats an even spread by 4-11 CV points </a:t>
             </a:r>
             <a:r>
-              <a:rPr sz="2800" dirty="0"/>
               <a:t>at every series length tested.</a:t>
             </a:r>
           </a:p>
           <a:p>
             <a:r>
-              <a:rPr sz="2800" b="1" dirty="0"/>
+              <a:rPr b="1"/>
               <a:t>Small bias penalty (1-6%), </a:t>
             </a:r>
             <a:r>
-              <a:rPr sz="2800" dirty="0"/>
               <a:t>no worse than the alternatives.</a:t>
             </a:r>
           </a:p>
           <a:p>
             <a:r>
-              <a:rPr sz="2800" dirty="0"/>
               <a:t>The program already does this implicitly, staffing the opening weekend and the biggest tides.</a:t>
             </a:r>
           </a:p>
           <a:p>
             <a:r>
-              <a:rPr sz="2800" b="1" dirty="0"/>
+              <a:rPr b="1"/>
               <a:t>It is correct. </a:t>
             </a:r>
             <a:r>
-              <a:rPr sz="2800" dirty="0"/>
               <a:t>Which days will be largest is well predicted by the schedule, tide height, and day of week.</a:t>
             </a:r>
           </a:p>
@@ -8829,301 +10000,6 @@
         <a:sysClr val="window" lastClr="FFFFFF"/>
       </a:lt1>
       <a:dk2>
-        <a:srgbClr val="44546A"/>
-      </a:dk2>
-      <a:lt2>
-        <a:srgbClr val="E7E6E6"/>
-      </a:lt2>
-      <a:accent1>
-        <a:srgbClr val="4472C4"/>
-      </a:accent1>
-      <a:accent2>
-        <a:srgbClr val="ED7D31"/>
-      </a:accent2>
-      <a:accent3>
-        <a:srgbClr val="A5A5A5"/>
-      </a:accent3>
-      <a:accent4>
-        <a:srgbClr val="FFC000"/>
-      </a:accent4>
-      <a:accent5>
-        <a:srgbClr val="5B9BD5"/>
-      </a:accent5>
-      <a:accent6>
-        <a:srgbClr val="70AD47"/>
-      </a:accent6>
-      <a:hlink>
-        <a:srgbClr val="0563C1"/>
-      </a:hlink>
-      <a:folHlink>
-        <a:srgbClr val="954F72"/>
-      </a:folHlink>
-    </a:clrScheme>
-    <a:fontScheme name="Office">
-      <a:majorFont>
-        <a:latin typeface="Calibri Light" panose="020F0302020204030204"/>
-        <a:ea typeface=""/>
-        <a:cs typeface=""/>
-        <a:font script="Jpan" typeface="游ゴシック Light"/>
-        <a:font script="Hang" typeface="맑은 고딕"/>
-        <a:font script="Hans" typeface="等线 Light"/>
-        <a:font script="Hant" typeface="新細明體"/>
-        <a:font script="Arab" typeface="Times New Roman"/>
-        <a:font script="Hebr" typeface="Times New Roman"/>
-        <a:font script="Thai" typeface="Angsana New"/>
-        <a:font script="Ethi" typeface="Nyala"/>
-        <a:font script="Beng" typeface="Vrinda"/>
-        <a:font script="Gujr" typeface="Shruti"/>
-        <a:font script="Khmr" typeface="MoolBoran"/>
-        <a:font script="Knda" typeface="Tunga"/>
-        <a:font script="Guru" typeface="Raavi"/>
-        <a:font script="Cans" typeface="Euphemia"/>
-        <a:font script="Cher" typeface="Plantagenet Cherokee"/>
-        <a:font script="Yiii" typeface="Microsoft Yi Baiti"/>
-        <a:font script="Tibt" typeface="Microsoft Himalaya"/>
-        <a:font script="Thaa" typeface="MV Boli"/>
-        <a:font script="Deva" typeface="Mangal"/>
-        <a:font script="Telu" typeface="Gautami"/>
-        <a:font script="Taml" typeface="Latha"/>
-        <a:font script="Syrc" typeface="Estrangelo Edessa"/>
-        <a:font script="Orya" typeface="Kalinga"/>
-        <a:font script="Mlym" typeface="Kartika"/>
-        <a:font script="Laoo" typeface="DokChampa"/>
-        <a:font script="Sinh" typeface="Iskoola Pota"/>
-        <a:font script="Mong" typeface="Mongolian Baiti"/>
-        <a:font script="Viet" typeface="Times New Roman"/>
-        <a:font script="Uigh" typeface="Microsoft Uighur"/>
-        <a:font script="Geor" typeface="Sylfaen"/>
-        <a:font script="Armn" typeface="Arial"/>
-        <a:font script="Bugi" typeface="Leelawadee UI"/>
-        <a:font script="Bopo" typeface="Microsoft JhengHei"/>
-        <a:font script="Java" typeface="Javanese Text"/>
-        <a:font script="Lisu" typeface="Segoe UI"/>
-        <a:font script="Mymr" typeface="Myanmar Text"/>
-        <a:font script="Nkoo" typeface="Ebrima"/>
-        <a:font script="Olck" typeface="Nirmala UI"/>
-        <a:font script="Osma" typeface="Ebrima"/>
-        <a:font script="Phag" typeface="Phagspa"/>
-        <a:font script="Syrn" typeface="Estrangelo Edessa"/>
-        <a:font script="Syrj" typeface="Estrangelo Edessa"/>
-        <a:font script="Syre" typeface="Estrangelo Edessa"/>
-        <a:font script="Sora" typeface="Nirmala UI"/>
-        <a:font script="Tale" typeface="Microsoft Tai Le"/>
-        <a:font script="Talu" typeface="Microsoft New Tai Lue"/>
-        <a:font script="Tfng" typeface="Ebrima"/>
-      </a:majorFont>
-      <a:minorFont>
-        <a:latin typeface="Calibri" panose="020F0502020204030204"/>
-        <a:ea typeface=""/>
-        <a:cs typeface=""/>
-        <a:font script="Jpan" typeface="游ゴシック"/>
-        <a:font script="Hang" typeface="맑은 고딕"/>
-        <a:font script="Hans" typeface="等线"/>
-        <a:font script="Hant" typeface="新細明體"/>
-        <a:font script="Arab" typeface="Arial"/>
-        <a:font script="Hebr" typeface="Arial"/>
-        <a:font script="Thai" typeface="Cordia New"/>
-        <a:font script="Ethi" typeface="Nyala"/>
-        <a:font script="Beng" typeface="Vrinda"/>
-        <a:font script="Gujr" typeface="Shruti"/>
-        <a:font script="Khmr" typeface="DaunPenh"/>
-        <a:font script="Knda" typeface="Tunga"/>
-        <a:font script="Guru" typeface="Raavi"/>
-        <a:font script="Cans" typeface="Euphemia"/>
-        <a:font script="Cher" typeface="Plantagenet Cherokee"/>
-        <a:font script="Yiii" typeface="Microsoft Yi Baiti"/>
-        <a:font script="Tibt" typeface="Microsoft Himalaya"/>
-        <a:font script="Thaa" typeface="MV Boli"/>
-        <a:font script="Deva" typeface="Mangal"/>
-        <a:font script="Telu" typeface="Gautami"/>
-        <a:font script="Taml" typeface="Latha"/>
-        <a:font script="Syrc" typeface="Estrangelo Edessa"/>
-        <a:font script="Orya" typeface="Kalinga"/>
-        <a:font script="Mlym" typeface="Kartika"/>
-        <a:font script="Laoo" typeface="DokChampa"/>
-        <a:font script="Sinh" typeface="Iskoola Pota"/>
-        <a:font script="Mong" typeface="Mongolian Baiti"/>
-        <a:font script="Viet" typeface="Arial"/>
-        <a:font script="Uigh" typeface="Microsoft Uighur"/>
-        <a:font script="Geor" typeface="Sylfaen"/>
-        <a:font script="Armn" typeface="Arial"/>
-        <a:font script="Bugi" typeface="Leelawadee UI"/>
-        <a:font script="Bopo" typeface="Microsoft JhengHei"/>
-        <a:font script="Java" typeface="Javanese Text"/>
-        <a:font script="Lisu" typeface="Segoe UI"/>
-        <a:font script="Mymr" typeface="Myanmar Text"/>
-        <a:font script="Nkoo" typeface="Ebrima"/>
-        <a:font script="Olck" typeface="Nirmala UI"/>
-        <a:font script="Osma" typeface="Ebrima"/>
-        <a:font script="Phag" typeface="Phagspa"/>
-        <a:font script="Syrn" typeface="Estrangelo Edessa"/>
-        <a:font script="Syrj" typeface="Estrangelo Edessa"/>
-        <a:font script="Syre" typeface="Estrangelo Edessa"/>
-        <a:font script="Sora" typeface="Nirmala UI"/>
-        <a:font script="Tale" typeface="Microsoft Tai Le"/>
-        <a:font script="Talu" typeface="Microsoft New Tai Lue"/>
-        <a:font script="Tfng" typeface="Ebrima"/>
-      </a:minorFont>
-    </a:fontScheme>
-    <a:fmtScheme name="Office">
-      <a:fillStyleLst>
-        <a:solidFill>
-          <a:schemeClr val="phClr"/>
-        </a:solidFill>
-        <a:gradFill rotWithShape="1">
-          <a:gsLst>
-            <a:gs pos="0">
-              <a:schemeClr val="phClr">
-                <a:lumMod val="110000"/>
-                <a:satMod val="105000"/>
-                <a:tint val="67000"/>
-              </a:schemeClr>
-            </a:gs>
-            <a:gs pos="50000">
-              <a:schemeClr val="phClr">
-                <a:lumMod val="105000"/>
-                <a:satMod val="103000"/>
-                <a:tint val="73000"/>
-              </a:schemeClr>
-            </a:gs>
-            <a:gs pos="100000">
-              <a:schemeClr val="phClr">
-                <a:lumMod val="105000"/>
-                <a:satMod val="109000"/>
-                <a:tint val="81000"/>
-              </a:schemeClr>
-            </a:gs>
-          </a:gsLst>
-          <a:lin ang="5400000" scaled="0"/>
-        </a:gradFill>
-        <a:gradFill rotWithShape="1">
-          <a:gsLst>
-            <a:gs pos="0">
-              <a:schemeClr val="phClr">
-                <a:satMod val="103000"/>
-                <a:lumMod val="102000"/>
-                <a:tint val="94000"/>
-              </a:schemeClr>
-            </a:gs>
-            <a:gs pos="50000">
-              <a:schemeClr val="phClr">
-                <a:satMod val="110000"/>
-                <a:lumMod val="100000"/>
-                <a:shade val="100000"/>
-              </a:schemeClr>
-            </a:gs>
-            <a:gs pos="100000">
-              <a:schemeClr val="phClr">
-                <a:lumMod val="99000"/>
-                <a:satMod val="120000"/>
-                <a:shade val="78000"/>
-              </a:schemeClr>
-            </a:gs>
-          </a:gsLst>
-          <a:lin ang="5400000" scaled="0"/>
-        </a:gradFill>
-      </a:fillStyleLst>
-      <a:lnStyleLst>
-        <a:ln w="6350" cap="flat" cmpd="sng" algn="ctr">
-          <a:solidFill>
-            <a:schemeClr val="phClr"/>
-          </a:solidFill>
-          <a:prstDash val="solid"/>
-          <a:miter lim="800000"/>
-        </a:ln>
-        <a:ln w="12700" cap="flat" cmpd="sng" algn="ctr">
-          <a:solidFill>
-            <a:schemeClr val="phClr"/>
-          </a:solidFill>
-          <a:prstDash val="solid"/>
-          <a:miter lim="800000"/>
-        </a:ln>
-        <a:ln w="19050" cap="flat" cmpd="sng" algn="ctr">
-          <a:solidFill>
-            <a:schemeClr val="phClr"/>
-          </a:solidFill>
-          <a:prstDash val="solid"/>
-          <a:miter lim="800000"/>
-        </a:ln>
-      </a:lnStyleLst>
-      <a:effectStyleLst>
-        <a:effectStyle>
-          <a:effectLst/>
-        </a:effectStyle>
-        <a:effectStyle>
-          <a:effectLst/>
-        </a:effectStyle>
-        <a:effectStyle>
-          <a:effectLst>
-            <a:outerShdw blurRad="57150" dist="19050" dir="5400000" algn="ctr" rotWithShape="0">
-              <a:srgbClr val="000000">
-                <a:alpha val="63000"/>
-              </a:srgbClr>
-            </a:outerShdw>
-          </a:effectLst>
-        </a:effectStyle>
-      </a:effectStyleLst>
-      <a:bgFillStyleLst>
-        <a:solidFill>
-          <a:schemeClr val="phClr"/>
-        </a:solidFill>
-        <a:solidFill>
-          <a:schemeClr val="phClr">
-            <a:tint val="95000"/>
-            <a:satMod val="170000"/>
-          </a:schemeClr>
-        </a:solidFill>
-        <a:gradFill rotWithShape="1">
-          <a:gsLst>
-            <a:gs pos="0">
-              <a:schemeClr val="phClr">
-                <a:tint val="93000"/>
-                <a:satMod val="150000"/>
-                <a:shade val="98000"/>
-                <a:lumMod val="102000"/>
-              </a:schemeClr>
-            </a:gs>
-            <a:gs pos="50000">
-              <a:schemeClr val="phClr">
-                <a:tint val="98000"/>
-                <a:satMod val="130000"/>
-                <a:shade val="90000"/>
-                <a:lumMod val="103000"/>
-              </a:schemeClr>
-            </a:gs>
-            <a:gs pos="100000">
-              <a:schemeClr val="phClr">
-                <a:shade val="63000"/>
-                <a:satMod val="120000"/>
-              </a:schemeClr>
-            </a:gs>
-          </a:gsLst>
-          <a:lin ang="5400000" scaled="0"/>
-        </a:gradFill>
-      </a:bgFillStyleLst>
-    </a:fmtScheme>
-  </a:themeElements>
-  <a:objectDefaults/>
-  <a:extraClrSchemeLst/>
-  <a:extLst>
-    <a:ext uri="{05A4C25C-085E-4340-85A3-A5531E510DB2}">
-      <thm15:themeFamily xmlns:thm15="http://schemas.microsoft.com/office/thememl/2012/main" name="Office Theme" id="{62F939B6-93AF-4DB8-9C6B-D6C7DFDC589F}" vid="{4A3C46E8-61CC-4603-A589-7422A47A8E4A}"/>
-    </a:ext>
-  </a:extLst>
-</a:theme>
-</file>
-
-<file path=ppt/theme/theme3.xml><?xml version="1.0" encoding="utf-8"?>
-<a:theme xmlns:a="http://schemas.openxmlformats.org/drawingml/2006/main" name="Office Theme">
-  <a:themeElements>
-    <a:clrScheme name="Office">
-      <a:dk1>
-        <a:sysClr val="windowText" lastClr="000000"/>
-      </a:dk1>
-      <a:lt1>
-        <a:sysClr val="window" lastClr="FFFFFF"/>
-      </a:lt1>
-      <a:dk2>
         <a:srgbClr val="0E2841"/>
       </a:dk2>
       <a:lt2>
@@ -9428,30 +10304,327 @@
 </a:theme>
 </file>
 
-<file path=customXml/item1.xml><?xml version="1.0" encoding="utf-8"?>
-<?mso-contentType ?>
-<FormTemplates xmlns="http://schemas.microsoft.com/sharepoint/v3/contenttype/forms">
-  <Display>DocumentLibraryForm</Display>
-  <Edit>DocumentLibraryForm</Edit>
-  <New>DocumentLibraryForm</New>
-</FormTemplates>
+<file path=ppt/theme/theme3.xml><?xml version="1.0" encoding="utf-8"?>
+<a:theme xmlns:a="http://schemas.openxmlformats.org/drawingml/2006/main" name="Office Theme">
+  <a:themeElements>
+    <a:clrScheme name="Office">
+      <a:dk1>
+        <a:sysClr val="windowText" lastClr="000000"/>
+      </a:dk1>
+      <a:lt1>
+        <a:sysClr val="window" lastClr="FFFFFF"/>
+      </a:lt1>
+      <a:dk2>
+        <a:srgbClr val="1F497D"/>
+      </a:dk2>
+      <a:lt2>
+        <a:srgbClr val="EEECE1"/>
+      </a:lt2>
+      <a:accent1>
+        <a:srgbClr val="4F81BD"/>
+      </a:accent1>
+      <a:accent2>
+        <a:srgbClr val="C0504D"/>
+      </a:accent2>
+      <a:accent3>
+        <a:srgbClr val="9BBB59"/>
+      </a:accent3>
+      <a:accent4>
+        <a:srgbClr val="8064A2"/>
+      </a:accent4>
+      <a:accent5>
+        <a:srgbClr val="4BACC6"/>
+      </a:accent5>
+      <a:accent6>
+        <a:srgbClr val="F79646"/>
+      </a:accent6>
+      <a:hlink>
+        <a:srgbClr val="0000FF"/>
+      </a:hlink>
+      <a:folHlink>
+        <a:srgbClr val="800080"/>
+      </a:folHlink>
+    </a:clrScheme>
+    <a:fontScheme name="Office">
+      <a:majorFont>
+        <a:latin typeface="Calibri"/>
+        <a:ea typeface=""/>
+        <a:cs typeface=""/>
+        <a:font script="Jpan" typeface="ＭＳ Ｐゴシック"/>
+        <a:font script="Hang" typeface="맑은 고딕"/>
+        <a:font script="Hans" typeface="宋体"/>
+        <a:font script="Hant" typeface="新細明體"/>
+        <a:font script="Arab" typeface="Times New Roman"/>
+        <a:font script="Hebr" typeface="Times New Roman"/>
+        <a:font script="Thai" typeface="Angsana New"/>
+        <a:font script="Ethi" typeface="Nyala"/>
+        <a:font script="Beng" typeface="Vrinda"/>
+        <a:font script="Gujr" typeface="Shruti"/>
+        <a:font script="Khmr" typeface="MoolBoran"/>
+        <a:font script="Knda" typeface="Tunga"/>
+        <a:font script="Guru" typeface="Raavi"/>
+        <a:font script="Cans" typeface="Euphemia"/>
+        <a:font script="Cher" typeface="Plantagenet Cherokee"/>
+        <a:font script="Yiii" typeface="Microsoft Yi Baiti"/>
+        <a:font script="Tibt" typeface="Microsoft Himalaya"/>
+        <a:font script="Thaa" typeface="MV Boli"/>
+        <a:font script="Deva" typeface="Mangal"/>
+        <a:font script="Telu" typeface="Gautami"/>
+        <a:font script="Taml" typeface="Latha"/>
+        <a:font script="Syrc" typeface="Estrangelo Edessa"/>
+        <a:font script="Orya" typeface="Kalinga"/>
+        <a:font script="Mlym" typeface="Kartika"/>
+        <a:font script="Laoo" typeface="DokChampa"/>
+        <a:font script="Sinh" typeface="Iskoola Pota"/>
+        <a:font script="Mong" typeface="Mongolian Baiti"/>
+        <a:font script="Viet" typeface="Times New Roman"/>
+        <a:font script="Uigh" typeface="Microsoft Uighur"/>
+        <a:font script="Geor" typeface="Sylfaen"/>
+      </a:majorFont>
+      <a:minorFont>
+        <a:latin typeface="Calibri"/>
+        <a:ea typeface=""/>
+        <a:cs typeface=""/>
+        <a:font script="Jpan" typeface="ＭＳ Ｐゴシック"/>
+        <a:font script="Hang" typeface="맑은 고딕"/>
+        <a:font script="Hans" typeface="宋体"/>
+        <a:font script="Hant" typeface="新細明體"/>
+        <a:font script="Arab" typeface="Arial"/>
+        <a:font script="Hebr" typeface="Arial"/>
+        <a:font script="Thai" typeface="Cordia New"/>
+        <a:font script="Ethi" typeface="Nyala"/>
+        <a:font script="Beng" typeface="Vrinda"/>
+        <a:font script="Gujr" typeface="Shruti"/>
+        <a:font script="Khmr" typeface="DaunPenh"/>
+        <a:font script="Knda" typeface="Tunga"/>
+        <a:font script="Guru" typeface="Raavi"/>
+        <a:font script="Cans" typeface="Euphemia"/>
+        <a:font script="Cher" typeface="Plantagenet Cherokee"/>
+        <a:font script="Yiii" typeface="Microsoft Yi Baiti"/>
+        <a:font script="Tibt" typeface="Microsoft Himalaya"/>
+        <a:font script="Thaa" typeface="MV Boli"/>
+        <a:font script="Deva" typeface="Mangal"/>
+        <a:font script="Telu" typeface="Gautami"/>
+        <a:font script="Taml" typeface="Latha"/>
+        <a:font script="Syrc" typeface="Estrangelo Edessa"/>
+        <a:font script="Orya" typeface="Kalinga"/>
+        <a:font script="Mlym" typeface="Kartika"/>
+        <a:font script="Laoo" typeface="DokChampa"/>
+        <a:font script="Sinh" typeface="Iskoola Pota"/>
+        <a:font script="Mong" typeface="Mongolian Baiti"/>
+        <a:font script="Viet" typeface="Arial"/>
+        <a:font script="Uigh" typeface="Microsoft Uighur"/>
+        <a:font script="Geor" typeface="Sylfaen"/>
+      </a:minorFont>
+    </a:fontScheme>
+    <a:fmtScheme name="Office">
+      <a:fillStyleLst>
+        <a:solidFill>
+          <a:schemeClr val="phClr"/>
+        </a:solidFill>
+        <a:gradFill rotWithShape="1">
+          <a:gsLst>
+            <a:gs pos="0">
+              <a:schemeClr val="phClr">
+                <a:tint val="50000"/>
+                <a:satMod val="300000"/>
+              </a:schemeClr>
+            </a:gs>
+            <a:gs pos="35000">
+              <a:schemeClr val="phClr">
+                <a:tint val="37000"/>
+                <a:satMod val="300000"/>
+              </a:schemeClr>
+            </a:gs>
+            <a:gs pos="100000">
+              <a:schemeClr val="phClr">
+                <a:tint val="15000"/>
+                <a:satMod val="350000"/>
+              </a:schemeClr>
+            </a:gs>
+          </a:gsLst>
+          <a:lin ang="16200000" scaled="1"/>
+        </a:gradFill>
+        <a:gradFill rotWithShape="1">
+          <a:gsLst>
+            <a:gs pos="0">
+              <a:schemeClr val="phClr">
+                <a:tint val="100000"/>
+                <a:shade val="100000"/>
+                <a:satMod val="130000"/>
+              </a:schemeClr>
+            </a:gs>
+            <a:gs pos="100000">
+              <a:schemeClr val="phClr">
+                <a:tint val="50000"/>
+                <a:shade val="100000"/>
+                <a:satMod val="350000"/>
+              </a:schemeClr>
+            </a:gs>
+          </a:gsLst>
+          <a:lin ang="16200000" scaled="0"/>
+        </a:gradFill>
+      </a:fillStyleLst>
+      <a:lnStyleLst>
+        <a:ln w="9525" cap="flat" cmpd="sng" algn="ctr">
+          <a:solidFill>
+            <a:schemeClr val="phClr">
+              <a:shade val="95000"/>
+              <a:satMod val="105000"/>
+            </a:schemeClr>
+          </a:solidFill>
+          <a:prstDash val="solid"/>
+        </a:ln>
+        <a:ln w="25400" cap="flat" cmpd="sng" algn="ctr">
+          <a:solidFill>
+            <a:schemeClr val="phClr"/>
+          </a:solidFill>
+          <a:prstDash val="solid"/>
+        </a:ln>
+        <a:ln w="38100" cap="flat" cmpd="sng" algn="ctr">
+          <a:solidFill>
+            <a:schemeClr val="phClr"/>
+          </a:solidFill>
+          <a:prstDash val="solid"/>
+        </a:ln>
+      </a:lnStyleLst>
+      <a:effectStyleLst>
+        <a:effectStyle>
+          <a:effectLst>
+            <a:outerShdw blurRad="40000" dist="20000" dir="5400000" rotWithShape="0">
+              <a:srgbClr val="000000">
+                <a:alpha val="38000"/>
+              </a:srgbClr>
+            </a:outerShdw>
+          </a:effectLst>
+        </a:effectStyle>
+        <a:effectStyle>
+          <a:effectLst>
+            <a:outerShdw blurRad="40000" dist="23000" dir="5400000" rotWithShape="0">
+              <a:srgbClr val="000000">
+                <a:alpha val="35000"/>
+              </a:srgbClr>
+            </a:outerShdw>
+          </a:effectLst>
+        </a:effectStyle>
+        <a:effectStyle>
+          <a:effectLst>
+            <a:outerShdw blurRad="40000" dist="23000" dir="5400000" rotWithShape="0">
+              <a:srgbClr val="000000">
+                <a:alpha val="35000"/>
+              </a:srgbClr>
+            </a:outerShdw>
+          </a:effectLst>
+          <a:scene3d>
+            <a:camera prst="orthographicFront">
+              <a:rot lat="0" lon="0" rev="0"/>
+            </a:camera>
+            <a:lightRig rig="threePt" dir="t">
+              <a:rot lat="0" lon="0" rev="1200000"/>
+            </a:lightRig>
+          </a:scene3d>
+          <a:sp3d>
+            <a:bevelT w="63500" h="25400"/>
+          </a:sp3d>
+        </a:effectStyle>
+      </a:effectStyleLst>
+      <a:bgFillStyleLst>
+        <a:solidFill>
+          <a:schemeClr val="phClr"/>
+        </a:solidFill>
+        <a:gradFill rotWithShape="1">
+          <a:gsLst>
+            <a:gs pos="0">
+              <a:schemeClr val="phClr">
+                <a:tint val="40000"/>
+                <a:satMod val="350000"/>
+              </a:schemeClr>
+            </a:gs>
+            <a:gs pos="40000">
+              <a:schemeClr val="phClr">
+                <a:tint val="45000"/>
+                <a:shade val="99000"/>
+                <a:satMod val="350000"/>
+              </a:schemeClr>
+            </a:gs>
+            <a:gs pos="100000">
+              <a:schemeClr val="phClr">
+                <a:shade val="20000"/>
+                <a:satMod val="255000"/>
+              </a:schemeClr>
+            </a:gs>
+          </a:gsLst>
+          <a:path path="circle">
+            <a:fillToRect l="50000" t="-80000" r="50000" b="180000"/>
+          </a:path>
+        </a:gradFill>
+        <a:gradFill rotWithShape="1">
+          <a:gsLst>
+            <a:gs pos="0">
+              <a:schemeClr val="phClr">
+                <a:tint val="80000"/>
+                <a:satMod val="300000"/>
+              </a:schemeClr>
+            </a:gs>
+            <a:gs pos="100000">
+              <a:schemeClr val="phClr">
+                <a:shade val="30000"/>
+                <a:satMod val="200000"/>
+              </a:schemeClr>
+            </a:gs>
+          </a:gsLst>
+          <a:path path="circle">
+            <a:fillToRect l="50000" t="50000" r="50000" b="50000"/>
+          </a:path>
+        </a:gradFill>
+      </a:bgFillStyleLst>
+    </a:fmtScheme>
+  </a:themeElements>
+  <a:objectDefaults>
+    <a:spDef>
+      <a:spPr/>
+      <a:bodyPr/>
+      <a:lstStyle/>
+      <a:style>
+        <a:lnRef idx="1">
+          <a:schemeClr val="accent1"/>
+        </a:lnRef>
+        <a:fillRef idx="3">
+          <a:schemeClr val="accent1"/>
+        </a:fillRef>
+        <a:effectRef idx="2">
+          <a:schemeClr val="accent1"/>
+        </a:effectRef>
+        <a:fontRef idx="minor">
+          <a:schemeClr val="lt1"/>
+        </a:fontRef>
+      </a:style>
+    </a:spDef>
+    <a:lnDef>
+      <a:spPr/>
+      <a:bodyPr/>
+      <a:lstStyle/>
+      <a:style>
+        <a:lnRef idx="2">
+          <a:schemeClr val="accent1"/>
+        </a:lnRef>
+        <a:fillRef idx="0">
+          <a:schemeClr val="accent1"/>
+        </a:fillRef>
+        <a:effectRef idx="1">
+          <a:schemeClr val="accent1"/>
+        </a:effectRef>
+        <a:fontRef idx="minor">
+          <a:schemeClr val="tx1"/>
+        </a:fontRef>
+      </a:style>
+    </a:lnDef>
+  </a:objectDefaults>
+  <a:extraClrSchemeLst/>
+</a:theme>
 </file>
 
-<file path=customXml/item2.xml><?xml version="1.0" encoding="utf-8"?>
-<p:properties xmlns:p="http://schemas.microsoft.com/office/2006/metadata/properties" xmlns:xsi="http://www.w3.org/2001/XMLSchema-instance" xmlns:pc="http://schemas.microsoft.com/office/infopath/2007/PartnerControls">
-  <documentManagement>
-    <_ip_UnifiedCompliancePolicyUIAction xmlns="http://schemas.microsoft.com/sharepoint/v3" xsi:nil="true"/>
-    <_ip_UnifiedCompliancePolicyProperties xmlns="http://schemas.microsoft.com/sharepoint/v3" xsi:nil="true"/>
-    <lcf76f155ced4ddcb4097134ff3c332f xmlns="c55fcec3-bb2d-4ee6-a56c-bdfd532525fc">
-      <Terms xmlns="http://schemas.microsoft.com/office/infopath/2007/PartnerControls"/>
-    </lcf76f155ced4ddcb4097134ff3c332f>
-    <TaxCatchAll xmlns="73c3c465-f3d4-4d37-9c58-e2ee535ad8e0" xsi:nil="true"/>
-    <NameinDAM xmlns="c55fcec3-bb2d-4ee6-a56c-bdfd532525fc" xsi:nil="true"/>
-  </documentManagement>
-</p:properties>
-</file>
-
-<file path=customXml/item3.xml><?xml version="1.0" encoding="utf-8"?>
+<file path=customXml/item1.xml><?xml version="1.0" encoding="utf-8"?>
 <ct:contentTypeSchema xmlns:ct="http://schemas.microsoft.com/office/2006/metadata/contentType" xmlns:ma="http://schemas.microsoft.com/office/2006/metadata/properties/metaAttributes" ct:_="" ma:_="" ma:contentTypeName="Document" ma:contentTypeID="0x01010053DF6C379CEE474091FA722A741F562C" ma:contentTypeVersion="18" ma:contentTypeDescription="Create a new document." ma:contentTypeScope="" ma:versionID="6d943700fdf77bec9a4960ab6af060cd">
   <xsd:schema xmlns:xsd="http://www.w3.org/2001/XMLSchema" xmlns:xs="http://www.w3.org/2001/XMLSchema" xmlns:p="http://schemas.microsoft.com/office/2006/metadata/properties" xmlns:ns1="http://schemas.microsoft.com/sharepoint/v3" xmlns:ns2="c55fcec3-bb2d-4ee6-a56c-bdfd532525fc" xmlns:ns3="73c3c465-f3d4-4d37-9c58-e2ee535ad8e0" targetNamespace="http://schemas.microsoft.com/office/2006/metadata/properties" ma:root="true" ma:fieldsID="f5f2cddc585f7bcfd68998bfccb1991a" ns1:_="" ns2:_="" ns3:_="">
     <xsd:import namespace="http://schemas.microsoft.com/sharepoint/v3"/>
@@ -9711,10 +10884,45 @@
 </ct:contentTypeSchema>
 </file>
 
+<file path=customXml/item2.xml><?xml version="1.0" encoding="utf-8"?>
+<p:properties xmlns:p="http://schemas.microsoft.com/office/2006/metadata/properties" xmlns:xsi="http://www.w3.org/2001/XMLSchema-instance" xmlns:pc="http://schemas.microsoft.com/office/infopath/2007/PartnerControls">
+  <documentManagement>
+    <_ip_UnifiedCompliancePolicyUIAction xmlns="http://schemas.microsoft.com/sharepoint/v3" xsi:nil="true"/>
+    <_ip_UnifiedCompliancePolicyProperties xmlns="http://schemas.microsoft.com/sharepoint/v3" xsi:nil="true"/>
+    <lcf76f155ced4ddcb4097134ff3c332f xmlns="c55fcec3-bb2d-4ee6-a56c-bdfd532525fc">
+      <Terms xmlns="http://schemas.microsoft.com/office/infopath/2007/PartnerControls"/>
+    </lcf76f155ced4ddcb4097134ff3c332f>
+    <TaxCatchAll xmlns="73c3c465-f3d4-4d37-9c58-e2ee535ad8e0" xsi:nil="true"/>
+    <NameinDAM xmlns="c55fcec3-bb2d-4ee6-a56c-bdfd532525fc" xsi:nil="true"/>
+  </documentManagement>
+</p:properties>
+</file>
+
+<file path=customXml/item3.xml><?xml version="1.0" encoding="utf-8"?>
+<?mso-contentType ?>
+<FormTemplates xmlns="http://schemas.microsoft.com/sharepoint/v3/contenttype/forms">
+  <Display>DocumentLibraryForm</Display>
+  <Edit>DocumentLibraryForm</Edit>
+  <New>DocumentLibraryForm</New>
+</FormTemplates>
+</file>
+
 <file path=customXml/itemProps1.xml><?xml version="1.0" encoding="utf-8"?>
-<ds:datastoreItem xmlns:ds="http://schemas.openxmlformats.org/officeDocument/2006/customXml" ds:itemID="{01EA9719-73E1-4AAC-90C2-9E9ED399E0F4}">
+<ds:datastoreItem xmlns:ds="http://schemas.openxmlformats.org/officeDocument/2006/customXml" ds:itemID="{236337B2-684D-4381-98D1-02BFB3997964}">
   <ds:schemaRefs>
-    <ds:schemaRef ds:uri="http://schemas.microsoft.com/sharepoint/v3/contenttype/forms"/>
+    <ds:schemaRef ds:uri="http://schemas.microsoft.com/office/2006/metadata/contentType"/>
+    <ds:schemaRef ds:uri="http://schemas.microsoft.com/office/2006/metadata/properties/metaAttributes"/>
+    <ds:schemaRef ds:uri="http://www.w3.org/2001/XMLSchema"/>
+    <ds:schemaRef ds:uri="http://schemas.microsoft.com/office/2006/metadata/properties"/>
+    <ds:schemaRef ds:uri="http://schemas.microsoft.com/sharepoint/v3"/>
+    <ds:schemaRef ds:uri="c55fcec3-bb2d-4ee6-a56c-bdfd532525fc"/>
+    <ds:schemaRef ds:uri="73c3c465-f3d4-4d37-9c58-e2ee535ad8e0"/>
+    <ds:schemaRef ds:uri="http://schemas.microsoft.com/office/2006/documentManagement/types"/>
+    <ds:schemaRef ds:uri="http://schemas.microsoft.com/office/infopath/2007/PartnerControls"/>
+    <ds:schemaRef ds:uri="http://schemas.openxmlformats.org/package/2006/metadata/core-properties"/>
+    <ds:schemaRef ds:uri="http://purl.org/dc/elements/1.1/"/>
+    <ds:schemaRef ds:uri="http://purl.org/dc/terms/"/>
+    <ds:schemaRef ds:uri="http://schemas.microsoft.com/internal/obd"/>
   </ds:schemaRefs>
 </ds:datastoreItem>
 </file>
@@ -9738,21 +10946,9 @@
 </file>
 
 <file path=customXml/itemProps3.xml><?xml version="1.0" encoding="utf-8"?>
-<ds:datastoreItem xmlns:ds="http://schemas.openxmlformats.org/officeDocument/2006/customXml" ds:itemID="{236337B2-684D-4381-98D1-02BFB3997964}">
+<ds:datastoreItem xmlns:ds="http://schemas.openxmlformats.org/officeDocument/2006/customXml" ds:itemID="{01EA9719-73E1-4AAC-90C2-9E9ED399E0F4}">
   <ds:schemaRefs>
-    <ds:schemaRef ds:uri="http://schemas.microsoft.com/office/2006/metadata/contentType"/>
-    <ds:schemaRef ds:uri="http://schemas.microsoft.com/office/2006/metadata/properties/metaAttributes"/>
-    <ds:schemaRef ds:uri="http://www.w3.org/2001/XMLSchema"/>
-    <ds:schemaRef ds:uri="http://schemas.microsoft.com/office/2006/metadata/properties"/>
-    <ds:schemaRef ds:uri="http://schemas.microsoft.com/sharepoint/v3"/>
-    <ds:schemaRef ds:uri="c55fcec3-bb2d-4ee6-a56c-bdfd532525fc"/>
-    <ds:schemaRef ds:uri="73c3c465-f3d4-4d37-9c58-e2ee535ad8e0"/>
-    <ds:schemaRef ds:uri="http://schemas.microsoft.com/office/2006/documentManagement/types"/>
-    <ds:schemaRef ds:uri="http://schemas.microsoft.com/office/infopath/2007/PartnerControls"/>
-    <ds:schemaRef ds:uri="http://schemas.openxmlformats.org/package/2006/metadata/core-properties"/>
-    <ds:schemaRef ds:uri="http://purl.org/dc/elements/1.1/"/>
-    <ds:schemaRef ds:uri="http://purl.org/dc/terms/"/>
-    <ds:schemaRef ds:uri="http://schemas.microsoft.com/internal/obd"/>
+    <ds:schemaRef ds:uri="http://schemas.microsoft.com/sharepoint/v3/contenttype/forms"/>
   </ds:schemaRefs>
 </ds:datastoreItem>
 </file>

</xml_diff>